<commit_message>
V2: improved analysis (phases 1-7), interaction heatmaps, swap-set framework, 8-slide deck
- Notebook rebuilt with 7 phases: EDA, interaction analysis, policy rules & swap sets, efficient frontier
- Added FICO×DTI and FICO×Revol heatmaps (Phase 3)
- Swap-set evaluation function with good-to-bad ratio metrics (Phase 4)
- Efficient frontier chart; ruleset comparison (Phase 5)
- Phase 7 final recommendation: Ruleset D (FICO<680 OR Grade E/F/G OR Revol>80%)
- Slides rebuilt as 8-slide deck using figures/ (not figs/)
- Removed old figs/ folder and stale slides_v2/v3.pptx
- README updated with exact metrics and AI tools disclosure

Co-Authored-By: Claude Sonnet 4.6 <noreply@anthropic.com>
</commit_message>
<xml_diff>
--- a/slides.pptx
+++ b/slides.pptx
@@ -5,15 +5,16 @@
     <p:sldMasterId id="2147483648" r:id="rId1"/>
   </p:sldMasterIdLst>
   <p:sldIdLst>
-    <p:sldId id="256" r:id="rId7"/>
-    <p:sldId id="257" r:id="rId8"/>
-    <p:sldId id="258" r:id="rId9"/>
-    <p:sldId id="259" r:id="rId10"/>
-    <p:sldId id="260" r:id="rId11"/>
-    <p:sldId id="261" r:id="rId12"/>
-    <p:sldId id="262" r:id="rId13"/>
+    <p:sldId id="256" r:id="rId2"/>
+    <p:sldId id="257" r:id="rId3"/>
+    <p:sldId id="258" r:id="rId4"/>
+    <p:sldId id="259" r:id="rId5"/>
+    <p:sldId id="260" r:id="rId6"/>
+    <p:sldId id="261" r:id="rId7"/>
+    <p:sldId id="262" r:id="rId8"/>
+    <p:sldId id="263" r:id="rId9"/>
   </p:sldIdLst>
-  <p:sldSz cx="12191695" cy="6858000" type="screen4x3"/>
+  <p:sldSz cx="12192000" cy="6858000"/>
   <p:notesSz cx="6858000" cy="9144000"/>
   <p:defaultTextStyle>
     <a:defPPr>
@@ -110,6 +111,22 @@
       </a:defRPr>
     </a:lvl9pPr>
   </p:defaultTextStyle>
+  <p:extLst>
+    <p:ext uri="{EFAFB233-063F-42B5-8137-9DF3F51BA10A}">
+      <p15:sldGuideLst xmlns:p15="http://schemas.microsoft.com/office/powerpoint/2012/main">
+        <p15:guide id="1" orient="horz" pos="2160">
+          <p15:clr>
+            <a:srgbClr val="A4A3A4"/>
+          </p15:clr>
+        </p15:guide>
+        <p15:guide id="2" pos="2880">
+          <p15:clr>
+            <a:srgbClr val="A4A3A4"/>
+          </p15:clr>
+        </p15:guide>
+      </p15:sldGuideLst>
+    </p:ext>
+  </p:extLst>
 </p:presentation>
 </file>
 
@@ -151,10 +168,9 @@
           <a:lstStyle/>
           <a:p>
             <a:r>
-              <a:rPr lang="en-US" smtClean="0"/>
+              <a:rPr lang="en-US"/>
               <a:t>Click to edit Master title style</a:t>
             </a:r>
-            <a:endParaRPr lang="en-US"/>
           </a:p>
         </p:txBody>
       </p:sp>
@@ -270,10 +286,9 @@
           </a:lstStyle>
           <a:p>
             <a:r>
-              <a:rPr lang="en-US" smtClean="0"/>
+              <a:rPr lang="en-US"/>
               <a:t>Click to edit Master subtitle style</a:t>
             </a:r>
-            <a:endParaRPr lang="en-US"/>
           </a:p>
         </p:txBody>
       </p:sp>
@@ -294,7 +309,7 @@
           <a:p>
             <a:fld id="{5BCAD085-E8A6-8845-BD4E-CB4CCA059FC4}" type="datetimeFigureOut">
               <a:rPr lang="en-US" smtClean="0"/>
-              <a:t>1/27/13</a:t>
+              <a:t>3/6/26</a:t>
             </a:fld>
             <a:endParaRPr lang="en-US"/>
           </a:p>
@@ -388,10 +403,9 @@
           <a:lstStyle/>
           <a:p>
             <a:r>
-              <a:rPr lang="en-US" smtClean="0"/>
+              <a:rPr lang="en-US"/>
               <a:t>Click to edit Master title style</a:t>
             </a:r>
-            <a:endParaRPr lang="en-US"/>
           </a:p>
         </p:txBody>
       </p:sp>
@@ -412,38 +426,37 @@
           <a:p>
             <a:pPr lvl="0"/>
             <a:r>
-              <a:rPr lang="en-US" smtClean="0"/>
+              <a:rPr lang="en-US"/>
               <a:t>Click to edit Master text styles</a:t>
             </a:r>
           </a:p>
           <a:p>
             <a:pPr lvl="1"/>
             <a:r>
-              <a:rPr lang="en-US" smtClean="0"/>
+              <a:rPr lang="en-US"/>
               <a:t>Second level</a:t>
             </a:r>
           </a:p>
           <a:p>
             <a:pPr lvl="2"/>
             <a:r>
-              <a:rPr lang="en-US" smtClean="0"/>
+              <a:rPr lang="en-US"/>
               <a:t>Third level</a:t>
             </a:r>
           </a:p>
           <a:p>
             <a:pPr lvl="3"/>
             <a:r>
-              <a:rPr lang="en-US" smtClean="0"/>
+              <a:rPr lang="en-US"/>
               <a:t>Fourth level</a:t>
             </a:r>
           </a:p>
           <a:p>
             <a:pPr lvl="4"/>
             <a:r>
-              <a:rPr lang="en-US" smtClean="0"/>
+              <a:rPr lang="en-US"/>
               <a:t>Fifth level</a:t>
             </a:r>
-            <a:endParaRPr lang="en-US"/>
           </a:p>
         </p:txBody>
       </p:sp>
@@ -464,7 +477,7 @@
           <a:p>
             <a:fld id="{5BCAD085-E8A6-8845-BD4E-CB4CCA059FC4}" type="datetimeFigureOut">
               <a:rPr lang="en-US" smtClean="0"/>
-              <a:t>1/27/13</a:t>
+              <a:t>3/6/26</a:t>
             </a:fld>
             <a:endParaRPr lang="en-US"/>
           </a:p>
@@ -563,10 +576,9 @@
           <a:lstStyle/>
           <a:p>
             <a:r>
-              <a:rPr lang="en-US" smtClean="0"/>
+              <a:rPr lang="en-US"/>
               <a:t>Click to edit Master title style</a:t>
             </a:r>
-            <a:endParaRPr lang="en-US"/>
           </a:p>
         </p:txBody>
       </p:sp>
@@ -592,38 +604,37 @@
           <a:p>
             <a:pPr lvl="0"/>
             <a:r>
-              <a:rPr lang="en-US" smtClean="0"/>
+              <a:rPr lang="en-US"/>
               <a:t>Click to edit Master text styles</a:t>
             </a:r>
           </a:p>
           <a:p>
             <a:pPr lvl="1"/>
             <a:r>
-              <a:rPr lang="en-US" smtClean="0"/>
+              <a:rPr lang="en-US"/>
               <a:t>Second level</a:t>
             </a:r>
           </a:p>
           <a:p>
             <a:pPr lvl="2"/>
             <a:r>
-              <a:rPr lang="en-US" smtClean="0"/>
+              <a:rPr lang="en-US"/>
               <a:t>Third level</a:t>
             </a:r>
           </a:p>
           <a:p>
             <a:pPr lvl="3"/>
             <a:r>
-              <a:rPr lang="en-US" smtClean="0"/>
+              <a:rPr lang="en-US"/>
               <a:t>Fourth level</a:t>
             </a:r>
           </a:p>
           <a:p>
             <a:pPr lvl="4"/>
             <a:r>
-              <a:rPr lang="en-US" smtClean="0"/>
+              <a:rPr lang="en-US"/>
               <a:t>Fifth level</a:t>
             </a:r>
-            <a:endParaRPr lang="en-US"/>
           </a:p>
         </p:txBody>
       </p:sp>
@@ -644,7 +655,7 @@
           <a:p>
             <a:fld id="{5BCAD085-E8A6-8845-BD4E-CB4CCA059FC4}" type="datetimeFigureOut">
               <a:rPr lang="en-US" smtClean="0"/>
-              <a:t>1/27/13</a:t>
+              <a:t>3/6/26</a:t>
             </a:fld>
             <a:endParaRPr lang="en-US"/>
           </a:p>
@@ -738,10 +749,9 @@
           <a:lstStyle/>
           <a:p>
             <a:r>
-              <a:rPr lang="en-US" smtClean="0"/>
+              <a:rPr lang="en-US"/>
               <a:t>Click to edit Master title style</a:t>
             </a:r>
-            <a:endParaRPr lang="en-US"/>
           </a:p>
         </p:txBody>
       </p:sp>
@@ -762,38 +772,37 @@
           <a:p>
             <a:pPr lvl="0"/>
             <a:r>
-              <a:rPr lang="en-US" smtClean="0"/>
+              <a:rPr lang="en-US"/>
               <a:t>Click to edit Master text styles</a:t>
             </a:r>
           </a:p>
           <a:p>
             <a:pPr lvl="1"/>
             <a:r>
-              <a:rPr lang="en-US" smtClean="0"/>
+              <a:rPr lang="en-US"/>
               <a:t>Second level</a:t>
             </a:r>
           </a:p>
           <a:p>
             <a:pPr lvl="2"/>
             <a:r>
-              <a:rPr lang="en-US" smtClean="0"/>
+              <a:rPr lang="en-US"/>
               <a:t>Third level</a:t>
             </a:r>
           </a:p>
           <a:p>
             <a:pPr lvl="3"/>
             <a:r>
-              <a:rPr lang="en-US" smtClean="0"/>
+              <a:rPr lang="en-US"/>
               <a:t>Fourth level</a:t>
             </a:r>
           </a:p>
           <a:p>
             <a:pPr lvl="4"/>
             <a:r>
-              <a:rPr lang="en-US" smtClean="0"/>
+              <a:rPr lang="en-US"/>
               <a:t>Fifth level</a:t>
             </a:r>
-            <a:endParaRPr lang="en-US"/>
           </a:p>
         </p:txBody>
       </p:sp>
@@ -814,7 +823,7 @@
           <a:p>
             <a:fld id="{5BCAD085-E8A6-8845-BD4E-CB4CCA059FC4}" type="datetimeFigureOut">
               <a:rPr lang="en-US" smtClean="0"/>
-              <a:t>1/27/13</a:t>
+              <a:t>3/6/26</a:t>
             </a:fld>
             <a:endParaRPr lang="en-US"/>
           </a:p>
@@ -917,10 +926,9 @@
           </a:lstStyle>
           <a:p>
             <a:r>
-              <a:rPr lang="en-US" smtClean="0"/>
+              <a:rPr lang="en-US"/>
               <a:t>Click to edit Master title style</a:t>
             </a:r>
-            <a:endParaRPr lang="en-US"/>
           </a:p>
         </p:txBody>
       </p:sp>
@@ -1037,7 +1045,7 @@
           <a:p>
             <a:pPr lvl="0"/>
             <a:r>
-              <a:rPr lang="en-US" smtClean="0"/>
+              <a:rPr lang="en-US"/>
               <a:t>Click to edit Master text styles</a:t>
             </a:r>
           </a:p>
@@ -1060,7 +1068,7 @@
           <a:p>
             <a:fld id="{5BCAD085-E8A6-8845-BD4E-CB4CCA059FC4}" type="datetimeFigureOut">
               <a:rPr lang="en-US" smtClean="0"/>
-              <a:t>1/27/13</a:t>
+              <a:t>3/6/26</a:t>
             </a:fld>
             <a:endParaRPr lang="en-US"/>
           </a:p>
@@ -1154,10 +1162,9 @@
           <a:lstStyle/>
           <a:p>
             <a:r>
-              <a:rPr lang="en-US" smtClean="0"/>
+              <a:rPr lang="en-US"/>
               <a:t>Click to edit Master title style</a:t>
             </a:r>
-            <a:endParaRPr lang="en-US"/>
           </a:p>
         </p:txBody>
       </p:sp>
@@ -1211,38 +1218,37 @@
           <a:p>
             <a:pPr lvl="0"/>
             <a:r>
-              <a:rPr lang="en-US" smtClean="0"/>
+              <a:rPr lang="en-US"/>
               <a:t>Click to edit Master text styles</a:t>
             </a:r>
           </a:p>
           <a:p>
             <a:pPr lvl="1"/>
             <a:r>
-              <a:rPr lang="en-US" smtClean="0"/>
+              <a:rPr lang="en-US"/>
               <a:t>Second level</a:t>
             </a:r>
           </a:p>
           <a:p>
             <a:pPr lvl="2"/>
             <a:r>
-              <a:rPr lang="en-US" smtClean="0"/>
+              <a:rPr lang="en-US"/>
               <a:t>Third level</a:t>
             </a:r>
           </a:p>
           <a:p>
             <a:pPr lvl="3"/>
             <a:r>
-              <a:rPr lang="en-US" smtClean="0"/>
+              <a:rPr lang="en-US"/>
               <a:t>Fourth level</a:t>
             </a:r>
           </a:p>
           <a:p>
             <a:pPr lvl="4"/>
             <a:r>
-              <a:rPr lang="en-US" smtClean="0"/>
+              <a:rPr lang="en-US"/>
               <a:t>Fifth level</a:t>
             </a:r>
-            <a:endParaRPr lang="en-US"/>
           </a:p>
         </p:txBody>
       </p:sp>
@@ -1296,38 +1302,37 @@
           <a:p>
             <a:pPr lvl="0"/>
             <a:r>
-              <a:rPr lang="en-US" smtClean="0"/>
+              <a:rPr lang="en-US"/>
               <a:t>Click to edit Master text styles</a:t>
             </a:r>
           </a:p>
           <a:p>
             <a:pPr lvl="1"/>
             <a:r>
-              <a:rPr lang="en-US" smtClean="0"/>
+              <a:rPr lang="en-US"/>
               <a:t>Second level</a:t>
             </a:r>
           </a:p>
           <a:p>
             <a:pPr lvl="2"/>
             <a:r>
-              <a:rPr lang="en-US" smtClean="0"/>
+              <a:rPr lang="en-US"/>
               <a:t>Third level</a:t>
             </a:r>
           </a:p>
           <a:p>
             <a:pPr lvl="3"/>
             <a:r>
-              <a:rPr lang="en-US" smtClean="0"/>
+              <a:rPr lang="en-US"/>
               <a:t>Fourth level</a:t>
             </a:r>
           </a:p>
           <a:p>
             <a:pPr lvl="4"/>
             <a:r>
-              <a:rPr lang="en-US" smtClean="0"/>
+              <a:rPr lang="en-US"/>
               <a:t>Fifth level</a:t>
             </a:r>
-            <a:endParaRPr lang="en-US"/>
           </a:p>
         </p:txBody>
       </p:sp>
@@ -1348,7 +1353,7 @@
           <a:p>
             <a:fld id="{5BCAD085-E8A6-8845-BD4E-CB4CCA059FC4}" type="datetimeFigureOut">
               <a:rPr lang="en-US" smtClean="0"/>
-              <a:t>1/27/13</a:t>
+              <a:t>3/6/26</a:t>
             </a:fld>
             <a:endParaRPr lang="en-US"/>
           </a:p>
@@ -1446,10 +1451,9 @@
           </a:lstStyle>
           <a:p>
             <a:r>
-              <a:rPr lang="en-US" smtClean="0"/>
+              <a:rPr lang="en-US"/>
               <a:t>Click to edit Master title style</a:t>
             </a:r>
-            <a:endParaRPr lang="en-US"/>
           </a:p>
         </p:txBody>
       </p:sp>
@@ -1512,7 +1516,7 @@
           <a:p>
             <a:pPr lvl="0"/>
             <a:r>
-              <a:rPr lang="en-US" smtClean="0"/>
+              <a:rPr lang="en-US"/>
               <a:t>Click to edit Master text styles</a:t>
             </a:r>
           </a:p>
@@ -1568,38 +1572,37 @@
           <a:p>
             <a:pPr lvl="0"/>
             <a:r>
-              <a:rPr lang="en-US" smtClean="0"/>
+              <a:rPr lang="en-US"/>
               <a:t>Click to edit Master text styles</a:t>
             </a:r>
           </a:p>
           <a:p>
             <a:pPr lvl="1"/>
             <a:r>
-              <a:rPr lang="en-US" smtClean="0"/>
+              <a:rPr lang="en-US"/>
               <a:t>Second level</a:t>
             </a:r>
           </a:p>
           <a:p>
             <a:pPr lvl="2"/>
             <a:r>
-              <a:rPr lang="en-US" smtClean="0"/>
+              <a:rPr lang="en-US"/>
               <a:t>Third level</a:t>
             </a:r>
           </a:p>
           <a:p>
             <a:pPr lvl="3"/>
             <a:r>
-              <a:rPr lang="en-US" smtClean="0"/>
+              <a:rPr lang="en-US"/>
               <a:t>Fourth level</a:t>
             </a:r>
           </a:p>
           <a:p>
             <a:pPr lvl="4"/>
             <a:r>
-              <a:rPr lang="en-US" smtClean="0"/>
+              <a:rPr lang="en-US"/>
               <a:t>Fifth level</a:t>
             </a:r>
-            <a:endParaRPr lang="en-US"/>
           </a:p>
         </p:txBody>
       </p:sp>
@@ -1662,7 +1665,7 @@
           <a:p>
             <a:pPr lvl="0"/>
             <a:r>
-              <a:rPr lang="en-US" smtClean="0"/>
+              <a:rPr lang="en-US"/>
               <a:t>Click to edit Master text styles</a:t>
             </a:r>
           </a:p>
@@ -1718,38 +1721,37 @@
           <a:p>
             <a:pPr lvl="0"/>
             <a:r>
-              <a:rPr lang="en-US" smtClean="0"/>
+              <a:rPr lang="en-US"/>
               <a:t>Click to edit Master text styles</a:t>
             </a:r>
           </a:p>
           <a:p>
             <a:pPr lvl="1"/>
             <a:r>
-              <a:rPr lang="en-US" smtClean="0"/>
+              <a:rPr lang="en-US"/>
               <a:t>Second level</a:t>
             </a:r>
           </a:p>
           <a:p>
             <a:pPr lvl="2"/>
             <a:r>
-              <a:rPr lang="en-US" smtClean="0"/>
+              <a:rPr lang="en-US"/>
               <a:t>Third level</a:t>
             </a:r>
           </a:p>
           <a:p>
             <a:pPr lvl="3"/>
             <a:r>
-              <a:rPr lang="en-US" smtClean="0"/>
+              <a:rPr lang="en-US"/>
               <a:t>Fourth level</a:t>
             </a:r>
           </a:p>
           <a:p>
             <a:pPr lvl="4"/>
             <a:r>
-              <a:rPr lang="en-US" smtClean="0"/>
+              <a:rPr lang="en-US"/>
               <a:t>Fifth level</a:t>
             </a:r>
-            <a:endParaRPr lang="en-US"/>
           </a:p>
         </p:txBody>
       </p:sp>
@@ -1770,7 +1772,7 @@
           <a:p>
             <a:fld id="{5BCAD085-E8A6-8845-BD4E-CB4CCA059FC4}" type="datetimeFigureOut">
               <a:rPr lang="en-US" smtClean="0"/>
-              <a:t>1/27/13</a:t>
+              <a:t>3/6/26</a:t>
             </a:fld>
             <a:endParaRPr lang="en-US"/>
           </a:p>
@@ -1864,10 +1866,9 @@
           <a:lstStyle/>
           <a:p>
             <a:r>
-              <a:rPr lang="en-US" smtClean="0"/>
+              <a:rPr lang="en-US"/>
               <a:t>Click to edit Master title style</a:t>
             </a:r>
-            <a:endParaRPr lang="en-US"/>
           </a:p>
         </p:txBody>
       </p:sp>
@@ -1888,7 +1889,7 @@
           <a:p>
             <a:fld id="{5BCAD085-E8A6-8845-BD4E-CB4CCA059FC4}" type="datetimeFigureOut">
               <a:rPr lang="en-US" smtClean="0"/>
-              <a:t>1/27/13</a:t>
+              <a:t>3/6/26</a:t>
             </a:fld>
             <a:endParaRPr lang="en-US"/>
           </a:p>
@@ -1983,7 +1984,7 @@
           <a:p>
             <a:fld id="{5BCAD085-E8A6-8845-BD4E-CB4CCA059FC4}" type="datetimeFigureOut">
               <a:rPr lang="en-US" smtClean="0"/>
-              <a:t>1/27/13</a:t>
+              <a:t>3/6/26</a:t>
             </a:fld>
             <a:endParaRPr lang="en-US"/>
           </a:p>
@@ -2086,10 +2087,9 @@
           </a:lstStyle>
           <a:p>
             <a:r>
-              <a:rPr lang="en-US" smtClean="0"/>
+              <a:rPr lang="en-US"/>
               <a:t>Click to edit Master title style</a:t>
             </a:r>
-            <a:endParaRPr lang="en-US"/>
           </a:p>
         </p:txBody>
       </p:sp>
@@ -2143,38 +2143,37 @@
           <a:p>
             <a:pPr lvl="0"/>
             <a:r>
-              <a:rPr lang="en-US" smtClean="0"/>
+              <a:rPr lang="en-US"/>
               <a:t>Click to edit Master text styles</a:t>
             </a:r>
           </a:p>
           <a:p>
             <a:pPr lvl="1"/>
             <a:r>
-              <a:rPr lang="en-US" smtClean="0"/>
+              <a:rPr lang="en-US"/>
               <a:t>Second level</a:t>
             </a:r>
           </a:p>
           <a:p>
             <a:pPr lvl="2"/>
             <a:r>
-              <a:rPr lang="en-US" smtClean="0"/>
+              <a:rPr lang="en-US"/>
               <a:t>Third level</a:t>
             </a:r>
           </a:p>
           <a:p>
             <a:pPr lvl="3"/>
             <a:r>
-              <a:rPr lang="en-US" smtClean="0"/>
+              <a:rPr lang="en-US"/>
               <a:t>Fourth level</a:t>
             </a:r>
           </a:p>
           <a:p>
             <a:pPr lvl="4"/>
             <a:r>
-              <a:rPr lang="en-US" smtClean="0"/>
+              <a:rPr lang="en-US"/>
               <a:t>Fifth level</a:t>
             </a:r>
-            <a:endParaRPr lang="en-US"/>
           </a:p>
         </p:txBody>
       </p:sp>
@@ -2237,7 +2236,7 @@
           <a:p>
             <a:pPr lvl="0"/>
             <a:r>
-              <a:rPr lang="en-US" smtClean="0"/>
+              <a:rPr lang="en-US"/>
               <a:t>Click to edit Master text styles</a:t>
             </a:r>
           </a:p>
@@ -2260,7 +2259,7 @@
           <a:p>
             <a:fld id="{5BCAD085-E8A6-8845-BD4E-CB4CCA059FC4}" type="datetimeFigureOut">
               <a:rPr lang="en-US" smtClean="0"/>
-              <a:t>1/27/13</a:t>
+              <a:t>3/6/26</a:t>
             </a:fld>
             <a:endParaRPr lang="en-US"/>
           </a:p>
@@ -2363,10 +2362,9 @@
           </a:lstStyle>
           <a:p>
             <a:r>
-              <a:rPr lang="en-US" smtClean="0"/>
+              <a:rPr lang="en-US"/>
               <a:t>Click to edit Master title style</a:t>
             </a:r>
-            <a:endParaRPr lang="en-US"/>
           </a:p>
         </p:txBody>
       </p:sp>
@@ -2490,7 +2488,7 @@
           <a:p>
             <a:pPr lvl="0"/>
             <a:r>
-              <a:rPr lang="en-US" smtClean="0"/>
+              <a:rPr lang="en-US"/>
               <a:t>Click to edit Master text styles</a:t>
             </a:r>
           </a:p>
@@ -2513,7 +2511,7 @@
           <a:p>
             <a:fld id="{5BCAD085-E8A6-8845-BD4E-CB4CCA059FC4}" type="datetimeFigureOut">
               <a:rPr lang="en-US" smtClean="0"/>
-              <a:t>1/27/13</a:t>
+              <a:t>3/6/26</a:t>
             </a:fld>
             <a:endParaRPr lang="en-US"/>
           </a:p>
@@ -2622,10 +2620,9 @@
           <a:lstStyle/>
           <a:p>
             <a:r>
-              <a:rPr lang="en-US" smtClean="0"/>
+              <a:rPr lang="en-US"/>
               <a:t>Click to edit Master title style</a:t>
             </a:r>
-            <a:endParaRPr lang="en-US"/>
           </a:p>
         </p:txBody>
       </p:sp>
@@ -2656,38 +2653,37 @@
           <a:p>
             <a:pPr lvl="0"/>
             <a:r>
-              <a:rPr lang="en-US" smtClean="0"/>
+              <a:rPr lang="en-US"/>
               <a:t>Click to edit Master text styles</a:t>
             </a:r>
           </a:p>
           <a:p>
             <a:pPr lvl="1"/>
             <a:r>
-              <a:rPr lang="en-US" smtClean="0"/>
+              <a:rPr lang="en-US"/>
               <a:t>Second level</a:t>
             </a:r>
           </a:p>
           <a:p>
             <a:pPr lvl="2"/>
             <a:r>
-              <a:rPr lang="en-US" smtClean="0"/>
+              <a:rPr lang="en-US"/>
               <a:t>Third level</a:t>
             </a:r>
           </a:p>
           <a:p>
             <a:pPr lvl="3"/>
             <a:r>
-              <a:rPr lang="en-US" smtClean="0"/>
+              <a:rPr lang="en-US"/>
               <a:t>Fourth level</a:t>
             </a:r>
           </a:p>
           <a:p>
             <a:pPr lvl="4"/>
             <a:r>
-              <a:rPr lang="en-US" smtClean="0"/>
+              <a:rPr lang="en-US"/>
               <a:t>Fifth level</a:t>
             </a:r>
-            <a:endParaRPr lang="en-US"/>
           </a:p>
         </p:txBody>
       </p:sp>
@@ -2726,7 +2722,7 @@
           <a:p>
             <a:fld id="{5BCAD085-E8A6-8845-BD4E-CB4CCA059FC4}" type="datetimeFigureOut">
               <a:rPr lang="en-US" smtClean="0"/>
-              <a:t>1/27/13</a:t>
+              <a:t>3/6/26</a:t>
             </a:fld>
             <a:endParaRPr lang="en-US"/>
           </a:p>
@@ -3085,7 +3081,7 @@
 </file>
 
 <file path=ppt/slides/slide1.xml><?xml version="1.0" encoding="utf-8"?>
-<p:sld xmlns:a="http://schemas.openxmlformats.org/drawingml/2006/main" xmlns:p="http://schemas.openxmlformats.org/presentationml/2006/main" xmlns:r="http://schemas.openxmlformats.org/officeDocument/2006/relationships">
+<p:sld xmlns:a="http://schemas.openxmlformats.org/drawingml/2006/main" xmlns:r="http://schemas.openxmlformats.org/officeDocument/2006/relationships" xmlns:p="http://schemas.openxmlformats.org/presentationml/2006/main">
   <p:cSld>
     <p:bg>
       <p:bgPr>
@@ -3101,7 +3097,14 @@
         <p:cNvGrpSpPr/>
         <p:nvPr/>
       </p:nvGrpSpPr>
-      <p:grpSpPr/>
+      <p:grpSpPr>
+        <a:xfrm>
+          <a:off x="0" y="0"/>
+          <a:ext cx="0" cy="0"/>
+          <a:chOff x="0" y="0"/>
+          <a:chExt cx="0" cy="0"/>
+        </a:xfrm>
+      </p:grpSpPr>
       <p:sp>
         <p:nvSpPr>
           <p:cNvPr id="2" name="Rectangle 1"/>
@@ -3110,17 +3113,18 @@
         </p:nvSpPr>
         <p:spPr>
           <a:xfrm>
-            <a:off x="0" y="6355080"/>
-            <a:ext cx="12191695" cy="502920"/>
+            <a:off x="0" y="0"/>
+            <a:ext cx="12192000" cy="6858000"/>
           </a:xfrm>
           <a:prstGeom prst="rect">
             <a:avLst/>
           </a:prstGeom>
           <a:solidFill>
-            <a:srgbClr val="1A5EC8"/>
+            <a:srgbClr val="F9FAFB"/>
           </a:solidFill>
-          <a:ln>
+          <a:ln w="9525" cap="flat" cmpd="sng" algn="ctr">
             <a:noFill/>
+            <a:prstDash val="solid"/>
           </a:ln>
         </p:spPr>
         <p:style>
@@ -3142,6 +3146,7 @@
           <a:lstStyle/>
           <a:p>
             <a:pPr algn="ctr"/>
+            <a:endParaRPr/>
           </a:p>
         </p:txBody>
       </p:sp>
@@ -3153,14 +3158,14 @@
         </p:nvSpPr>
         <p:spPr>
           <a:xfrm>
-            <a:off x="0" y="6309360"/>
-            <a:ext cx="3200400" cy="73152"/>
+            <a:off x="635000" y="1714500"/>
+            <a:ext cx="50800" cy="1778000"/>
           </a:xfrm>
           <a:prstGeom prst="rect">
             <a:avLst/>
           </a:prstGeom>
           <a:solidFill>
-            <a:srgbClr val="EF5350"/>
+            <a:srgbClr val="3B82F6"/>
           </a:solidFill>
           <a:ln>
             <a:noFill/>
@@ -3185,6 +3190,7 @@
           <a:lstStyle/>
           <a:p>
             <a:pPr algn="ctr"/>
+            <a:endParaRPr/>
           </a:p>
         </p:txBody>
       </p:sp>
@@ -3197,7 +3203,7 @@
         <p:spPr>
           <a:xfrm>
             <a:off x="822960" y="1645920"/>
-            <a:ext cx="10515600" cy="2011680"/>
+            <a:ext cx="10515600" cy="1754326"/>
           </a:xfrm>
           <a:prstGeom prst="rect">
             <a:avLst/>
@@ -3212,10 +3218,12 @@
           <a:p>
             <a:pPr algn="l"/>
             <a:r>
-              <a:rPr b="1" sz="4400">
-                <a:solidFill>
-                  <a:srgbClr val="FFFFFF"/>
-                </a:solidFill>
+              <a:rPr sz="5400" b="1" dirty="0">
+                <a:solidFill>
+                  <a:srgbClr val="0A0E27"/>
+                </a:solidFill>
+                <a:latin typeface="Century Gothic"/>
+                <a:cs typeface="Segoe UI Semibold"/>
               </a:rPr>
               <a:t>Are We Lending to
 the Right Borrowers?</a:t>
@@ -3247,10 +3255,12 @@
           <a:p>
             <a:pPr algn="l"/>
             <a:r>
-              <a:rPr sz="2200" b="0" i="0">
-                <a:solidFill>
-                  <a:srgbClr val="BBDEFB"/>
-                </a:solidFill>
+              <a:rPr sz="2000" b="0" i="0">
+                <a:solidFill>
+                  <a:srgbClr val="64748B"/>
+                </a:solidFill>
+                <a:latin typeface="Century Gothic"/>
+                <a:cs typeface="Segoe UI"/>
               </a:rPr>
               <a:t>Consumer Credit Policy Analysis  ·  Lending Club 2007–2020 Q3</a:t>
             </a:r>
@@ -3281,10 +3291,12 @@
           <a:p>
             <a:pPr algn="l"/>
             <a:r>
-              <a:rPr sz="1700" b="0" i="1">
-                <a:solidFill>
-                  <a:srgbClr val="90CAF9"/>
-                </a:solidFill>
+              <a:rPr sz="1700" b="1" i="1">
+                <a:solidFill>
+                  <a:srgbClr val="3B82F6"/>
+                </a:solidFill>
+                <a:latin typeface="Century Gothic"/>
+                <a:cs typeface="Segoe UI"/>
               </a:rPr>
               <a:t>ClarityPay Take-Home Exercise</a:t>
             </a:r>
@@ -3299,14 +3311,14 @@
         </p:nvSpPr>
         <p:spPr>
           <a:xfrm>
-            <a:off x="822960" y="5394960"/>
-            <a:ext cx="3840480" cy="502920"/>
+            <a:off x="812800" y="5384800"/>
+            <a:ext cx="4427794" cy="457200"/>
           </a:xfrm>
           <a:prstGeom prst="rect">
             <a:avLst/>
           </a:prstGeom>
           <a:solidFill>
-            <a:srgbClr val="1A5EC8"/>
+            <a:srgbClr val="3B82F6"/>
           </a:solidFill>
           <a:ln>
             <a:noFill/>
@@ -3331,6 +3343,7 @@
           <a:lstStyle/>
           <a:p>
             <a:pPr algn="ctr"/>
+            <a:endParaRPr/>
           </a:p>
         </p:txBody>
       </p:sp>
@@ -3342,8 +3355,8 @@
         </p:nvSpPr>
         <p:spPr>
           <a:xfrm>
-            <a:off x="868680" y="5394960"/>
-            <a:ext cx="3749039" cy="502920"/>
+            <a:off x="863600" y="5453624"/>
+            <a:ext cx="4376994" cy="307777"/>
           </a:xfrm>
           <a:prstGeom prst="rect">
             <a:avLst/>
@@ -3358,13 +3371,66 @@
           <a:p>
             <a:pPr algn="l"/>
             <a:r>
-              <a:rPr sz="1400" b="0" i="0">
+              <a:rPr sz="1400" b="1" i="0" dirty="0">
                 <a:solidFill>
                   <a:srgbClr val="FFFFFF"/>
                 </a:solidFill>
+                <a:latin typeface="Century Gothic"/>
+                <a:cs typeface="Segoe UI"/>
               </a:rPr>
               <a:t>  1,860,331 completed loans  |  2007–2020 Q3</a:t>
             </a:r>
+          </a:p>
+        </p:txBody>
+      </p:sp>
+      <p:sp>
+        <p:nvSpPr>
+          <p:cNvPr id="12" name="Rectangle 11">
+            <a:extLst>
+              <a:ext uri="{FF2B5EF4-FFF2-40B4-BE49-F238E27FC236}">
+                <a16:creationId xmlns:a16="http://schemas.microsoft.com/office/drawing/2014/main" id="{90A34707-5098-AB47-999C-D2CCDA8D53DF}"/>
+              </a:ext>
+            </a:extLst>
+          </p:cNvPr>
+          <p:cNvSpPr/>
+          <p:nvPr/>
+        </p:nvSpPr>
+        <p:spPr>
+          <a:xfrm>
+            <a:off x="0" y="0"/>
+            <a:ext cx="12192000" cy="63500"/>
+          </a:xfrm>
+          <a:prstGeom prst="rect">
+            <a:avLst/>
+          </a:prstGeom>
+          <a:solidFill>
+            <a:srgbClr val="3B82F6"/>
+          </a:solidFill>
+          <a:ln w="9525" cap="flat" cmpd="sng" algn="ctr">
+            <a:noFill/>
+            <a:prstDash val="solid"/>
+          </a:ln>
+        </p:spPr>
+        <p:style>
+          <a:lnRef idx="1">
+            <a:schemeClr val="accent1"/>
+          </a:lnRef>
+          <a:fillRef idx="3">
+            <a:schemeClr val="accent1"/>
+          </a:fillRef>
+          <a:effectRef idx="2">
+            <a:schemeClr val="accent1"/>
+          </a:effectRef>
+          <a:fontRef idx="minor">
+            <a:schemeClr val="lt1"/>
+          </a:fontRef>
+        </p:style>
+        <p:txBody>
+          <a:bodyPr vertOverflow="clip" horzOverflow="clip" rtlCol="0" anchor="t"/>
+          <a:lstStyle/>
+          <a:p>
+            <a:pPr algn="l"/>
+            <a:endParaRPr lang="en-US"/>
           </a:p>
         </p:txBody>
       </p:sp>
@@ -3377,7 +3443,7 @@
 </file>
 
 <file path=ppt/slides/slide2.xml><?xml version="1.0" encoding="utf-8"?>
-<p:sld xmlns:a="http://schemas.openxmlformats.org/drawingml/2006/main" xmlns:p="http://schemas.openxmlformats.org/presentationml/2006/main" xmlns:r="http://schemas.openxmlformats.org/officeDocument/2006/relationships">
+<p:sld xmlns:a="http://schemas.openxmlformats.org/drawingml/2006/main" xmlns:r="http://schemas.openxmlformats.org/officeDocument/2006/relationships" xmlns:p="http://schemas.openxmlformats.org/presentationml/2006/main">
   <p:cSld>
     <p:spTree>
       <p:nvGrpSpPr>
@@ -3385,7 +3451,14 @@
         <p:cNvGrpSpPr/>
         <p:nvPr/>
       </p:nvGrpSpPr>
-      <p:grpSpPr/>
+      <p:grpSpPr>
+        <a:xfrm>
+          <a:off x="0" y="0"/>
+          <a:ext cx="0" cy="0"/>
+          <a:chOff x="0" y="0"/>
+          <a:chExt cx="0" cy="0"/>
+        </a:xfrm>
+      </p:grpSpPr>
       <p:sp>
         <p:nvSpPr>
           <p:cNvPr id="2" name="Rectangle 1"/>
@@ -3395,16 +3468,17 @@
         <p:spPr>
           <a:xfrm>
             <a:off x="0" y="0"/>
-            <a:ext cx="12191695" cy="1005840"/>
+            <a:ext cx="12192000" cy="6858000"/>
           </a:xfrm>
           <a:prstGeom prst="rect">
             <a:avLst/>
           </a:prstGeom>
           <a:solidFill>
-            <a:srgbClr val="0D47A1"/>
+            <a:srgbClr val="F9FAFB"/>
           </a:solidFill>
-          <a:ln>
+          <a:ln w="9525" cap="flat" cmpd="sng" algn="ctr">
             <a:noFill/>
+            <a:prstDash val="solid"/>
           </a:ln>
         </p:spPr>
         <p:style>
@@ -3426,6 +3500,7 @@
           <a:lstStyle/>
           <a:p>
             <a:pPr algn="ctr"/>
+            <a:endParaRPr/>
           </a:p>
         </p:txBody>
       </p:sp>
@@ -3437,8 +3512,8 @@
         </p:nvSpPr>
         <p:spPr>
           <a:xfrm>
-            <a:off x="320040" y="91440"/>
-            <a:ext cx="11521440" cy="777240"/>
+            <a:off x="317500" y="254000"/>
+            <a:ext cx="11518900" cy="635000"/>
           </a:xfrm>
           <a:prstGeom prst="rect">
             <a:avLst/>
@@ -3452,10 +3527,12 @@
           <a:lstStyle/>
           <a:p>
             <a:r>
-              <a:rPr b="1" sz="2700">
-                <a:solidFill>
-                  <a:srgbClr val="FFFFFF"/>
-                </a:solidFill>
+              <a:rPr sz="2200" b="1" dirty="0">
+                <a:solidFill>
+                  <a:srgbClr val="0A0E27"/>
+                </a:solidFill>
+                <a:latin typeface="Century Gothic"/>
+                <a:cs typeface="Segoe UI Semibold"/>
               </a:rPr>
               <a:t>1 in 5 Lending Club Loans Were Never Repaid</a:t>
             </a:r>
@@ -3510,10 +3587,12 @@
           <a:p>
             <a:pPr algn="l"/>
             <a:r>
-              <a:rPr sz="7200" b="1" i="0">
-                <a:solidFill>
-                  <a:srgbClr val="EF5350"/>
-                </a:solidFill>
+              <a:rPr sz="4800" b="1" i="0">
+                <a:solidFill>
+                  <a:srgbClr val="3B82F6"/>
+                </a:solidFill>
+                <a:latin typeface="Century Gothic"/>
+                <a:cs typeface="Segoe UI Semibold"/>
               </a:rPr>
               <a:t>19.5%</a:t>
             </a:r>
@@ -3544,10 +3623,12 @@
           <a:p>
             <a:pPr algn="l"/>
             <a:r>
-              <a:rPr sz="1900" b="0" i="0">
-                <a:solidFill>
-                  <a:srgbClr val="424242"/>
-                </a:solidFill>
+              <a:rPr sz="1600" b="0" i="0">
+                <a:solidFill>
+                  <a:srgbClr val="64748B"/>
+                </a:solidFill>
+                <a:latin typeface="Century Gothic"/>
+                <a:cs typeface="Segoe UI"/>
               </a:rPr>
               <a:t>charge-off (default) rate</a:t>
             </a:r>
@@ -3569,7 +3650,7 @@
             <a:avLst/>
           </a:prstGeom>
           <a:solidFill>
-            <a:srgbClr val="E0E0E0"/>
+            <a:srgbClr val="E2E8F0"/>
           </a:solidFill>
           <a:ln>
             <a:noFill/>
@@ -3594,6 +3675,7 @@
           <a:lstStyle/>
           <a:p>
             <a:pPr algn="ctr"/>
+            <a:endParaRPr/>
           </a:p>
         </p:txBody>
       </p:sp>
@@ -3625,10 +3707,12 @@
               </a:spcBef>
             </a:pPr>
             <a:r>
-              <a:rPr sz="1600">
-                <a:solidFill>
-                  <a:srgbClr val="424242"/>
-                </a:solidFill>
+              <a:rPr sz="1400">
+                <a:solidFill>
+                  <a:srgbClr val="0A0E27"/>
+                </a:solidFill>
+                <a:latin typeface="Century Gothic"/>
+                <a:cs typeface="Segoe UI"/>
               </a:rPr>
               <a:t>▸ 362,548 loans written off as uncollectible</a:t>
             </a:r>
@@ -3640,10 +3724,12 @@
               </a:spcBef>
             </a:pPr>
             <a:r>
-              <a:rPr sz="1600">
-                <a:solidFill>
-                  <a:srgbClr val="424242"/>
-                </a:solidFill>
+              <a:rPr sz="1400">
+                <a:solidFill>
+                  <a:srgbClr val="0A0E27"/>
+                </a:solidFill>
+                <a:latin typeface="Century Gothic"/>
+                <a:cs typeface="Segoe UI"/>
               </a:rPr>
               <a:t>▸ Each charge-off = 100% loss of outstanding principal</a:t>
             </a:r>
@@ -3655,10 +3741,12 @@
               </a:spcBef>
             </a:pPr>
             <a:r>
-              <a:rPr sz="1600">
-                <a:solidFill>
-                  <a:srgbClr val="424242"/>
-                </a:solidFill>
+              <a:rPr sz="1400">
+                <a:solidFill>
+                  <a:srgbClr val="0A0E27"/>
+                </a:solidFill>
+                <a:latin typeface="Century Gothic"/>
+                <a:cs typeface="Segoe UI"/>
               </a:rPr>
               <a:t>▸ Industry average for consumer installment: 2–5%</a:t>
             </a:r>
@@ -3670,10 +3758,12 @@
               </a:spcBef>
             </a:pPr>
             <a:r>
-              <a:rPr sz="1600">
-                <a:solidFill>
-                  <a:srgbClr val="424242"/>
-                </a:solidFill>
+              <a:rPr sz="1400">
+                <a:solidFill>
+                  <a:srgbClr val="0A0E27"/>
+                </a:solidFill>
+                <a:latin typeface="Century Gothic"/>
+                <a:cs typeface="Segoe UI"/>
               </a:rPr>
               <a:t>▸ LC's platform attracted near-prime / subprime borrowers</a:t>
             </a:r>
@@ -3685,10 +3775,12 @@
               </a:spcBef>
             </a:pPr>
             <a:r>
-              <a:rPr sz="1600">
-                <a:solidFill>
-                  <a:srgbClr val="424242"/>
-                </a:solidFill>
+              <a:rPr sz="1400">
+                <a:solidFill>
+                  <a:srgbClr val="0A0E27"/>
+                </a:solidFill>
+                <a:latin typeface="Century Gothic"/>
+                <a:cs typeface="Segoe UI"/>
               </a:rPr>
               <a:t>▸ Goal: identify high-risk borrowers before we lend</a:t>
             </a:r>
@@ -3704,7 +3796,7 @@
 </file>
 
 <file path=ppt/slides/slide3.xml><?xml version="1.0" encoding="utf-8"?>
-<p:sld xmlns:a="http://schemas.openxmlformats.org/drawingml/2006/main" xmlns:p="http://schemas.openxmlformats.org/presentationml/2006/main" xmlns:r="http://schemas.openxmlformats.org/officeDocument/2006/relationships">
+<p:sld xmlns:a="http://schemas.openxmlformats.org/drawingml/2006/main" xmlns:r="http://schemas.openxmlformats.org/officeDocument/2006/relationships" xmlns:p="http://schemas.openxmlformats.org/presentationml/2006/main">
   <p:cSld>
     <p:spTree>
       <p:nvGrpSpPr>
@@ -3712,7 +3804,14 @@
         <p:cNvGrpSpPr/>
         <p:nvPr/>
       </p:nvGrpSpPr>
-      <p:grpSpPr/>
+      <p:grpSpPr>
+        <a:xfrm>
+          <a:off x="0" y="0"/>
+          <a:ext cx="0" cy="0"/>
+          <a:chOff x="0" y="0"/>
+          <a:chExt cx="0" cy="0"/>
+        </a:xfrm>
+      </p:grpSpPr>
       <p:sp>
         <p:nvSpPr>
           <p:cNvPr id="2" name="Rectangle 1"/>
@@ -3722,16 +3821,17 @@
         <p:spPr>
           <a:xfrm>
             <a:off x="0" y="0"/>
-            <a:ext cx="12191695" cy="1005840"/>
+            <a:ext cx="12192000" cy="6858000"/>
           </a:xfrm>
           <a:prstGeom prst="rect">
             <a:avLst/>
           </a:prstGeom>
           <a:solidFill>
-            <a:srgbClr val="0D47A1"/>
+            <a:srgbClr val="F9FAFB"/>
           </a:solidFill>
-          <a:ln>
+          <a:ln w="9525" cap="flat" cmpd="sng" algn="ctr">
             <a:noFill/>
+            <a:prstDash val="solid"/>
           </a:ln>
         </p:spPr>
         <p:style>
@@ -3753,6 +3853,7 @@
           <a:lstStyle/>
           <a:p>
             <a:pPr algn="ctr"/>
+            <a:endParaRPr/>
           </a:p>
         </p:txBody>
       </p:sp>
@@ -3764,8 +3865,8 @@
         </p:nvSpPr>
         <p:spPr>
           <a:xfrm>
-            <a:off x="320040" y="91440"/>
-            <a:ext cx="11521440" cy="777240"/>
+            <a:off x="317500" y="254000"/>
+            <a:ext cx="8895384" cy="646331"/>
           </a:xfrm>
           <a:prstGeom prst="rect">
             <a:avLst/>
@@ -3779,20 +3880,24 @@
           <a:lstStyle/>
           <a:p>
             <a:r>
-              <a:rPr b="1" sz="2700">
-                <a:solidFill>
-                  <a:srgbClr val="FFFFFF"/>
-                </a:solidFill>
+              <a:rPr sz="2200" b="1" dirty="0">
+                <a:solidFill>
+                  <a:srgbClr val="0A0E27"/>
+                </a:solidFill>
+                <a:latin typeface="Century Gothic"/>
+                <a:cs typeface="Segoe UI"/>
               </a:rPr>
               <a:t>1.86 Million Completed Loans Analyzed</a:t>
             </a:r>
           </a:p>
           <a:p>
             <a:r>
-              <a:rPr sz="1500">
-                <a:solidFill>
-                  <a:srgbClr val="BBDEFB"/>
-                </a:solidFill>
+              <a:rPr sz="1400" b="1" dirty="0">
+                <a:solidFill>
+                  <a:srgbClr val="0A0E27"/>
+                </a:solidFill>
+                <a:latin typeface="Century Gothic"/>
+                <a:cs typeface="Segoe UI"/>
               </a:rPr>
               <a:t>Scope: Fully Paid or Charged Off only  ·  Origination-time features only  ·  No post-loan data leakage</a:t>
             </a:r>
@@ -3801,7 +3906,7 @@
       </p:sp>
       <p:pic>
         <p:nvPicPr>
-          <p:cNvPr id="4" name="Picture 3" descr="volume_bad_rate_by_year.png"/>
+          <p:cNvPr id="4" name="Picture 3" descr="volume_by_year.png"/>
           <p:cNvPicPr>
             <a:picLocks noChangeAspect="1"/>
           </p:cNvPicPr>
@@ -3849,8 +3954,10 @@
             <a:r>
               <a:rPr sz="1400" b="0" i="0">
                 <a:solidFill>
-                  <a:srgbClr val="757575"/>
-                </a:solidFill>
+                  <a:srgbClr val="64748B"/>
+                </a:solidFill>
+                <a:latin typeface="Century Gothic"/>
+                <a:cs typeface="Segoe UI"/>
               </a:rPr>
               <a:t>Total loans analyzed</a:t>
             </a:r>
@@ -3881,10 +3988,12 @@
           <a:p>
             <a:pPr algn="l"/>
             <a:r>
-              <a:rPr sz="2000" b="1" i="0">
-                <a:solidFill>
-                  <a:srgbClr val="424242"/>
-                </a:solidFill>
+              <a:rPr sz="2600" b="1" i="0">
+                <a:solidFill>
+                  <a:srgbClr val="3B82F6"/>
+                </a:solidFill>
+                <a:latin typeface="Century Gothic"/>
+                <a:cs typeface="Segoe UI Semibold"/>
               </a:rPr>
               <a:t>1,860,331</a:t>
             </a:r>
@@ -3906,7 +4015,7 @@
             <a:avLst/>
           </a:prstGeom>
           <a:solidFill>
-            <a:srgbClr val="F5F5F5"/>
+            <a:srgbClr val="E2E8F0"/>
           </a:solidFill>
           <a:ln>
             <a:noFill/>
@@ -3931,6 +4040,7 @@
           <a:lstStyle/>
           <a:p>
             <a:pPr algn="ctr"/>
+            <a:endParaRPr/>
           </a:p>
         </p:txBody>
       </p:sp>
@@ -3960,8 +4070,10 @@
             <a:r>
               <a:rPr sz="1400" b="0" i="0">
                 <a:solidFill>
-                  <a:srgbClr val="757575"/>
-                </a:solidFill>
+                  <a:srgbClr val="64748B"/>
+                </a:solidFill>
+                <a:latin typeface="Century Gothic"/>
+                <a:cs typeface="Segoe UI"/>
               </a:rPr>
               <a:t>Fully Paid</a:t>
             </a:r>
@@ -3994,8 +4106,10 @@
             <a:r>
               <a:rPr sz="2000" b="1" i="0">
                 <a:solidFill>
-                  <a:srgbClr val="424242"/>
-                </a:solidFill>
+                  <a:srgbClr val="0A0E27"/>
+                </a:solidFill>
+                <a:latin typeface="Century Gothic"/>
+                <a:cs typeface="Segoe UI Semibold"/>
               </a:rPr>
               <a:t>1,497,783  (80.5%)</a:t>
             </a:r>
@@ -4017,7 +4131,7 @@
             <a:avLst/>
           </a:prstGeom>
           <a:solidFill>
-            <a:srgbClr val="F5F5F5"/>
+            <a:srgbClr val="E2E8F0"/>
           </a:solidFill>
           <a:ln>
             <a:noFill/>
@@ -4042,6 +4156,7 @@
           <a:lstStyle/>
           <a:p>
             <a:pPr algn="ctr"/>
+            <a:endParaRPr/>
           </a:p>
         </p:txBody>
       </p:sp>
@@ -4071,8 +4186,10 @@
             <a:r>
               <a:rPr sz="1400" b="0" i="0">
                 <a:solidFill>
-                  <a:srgbClr val="757575"/>
-                </a:solidFill>
+                  <a:srgbClr val="64748B"/>
+                </a:solidFill>
+                <a:latin typeface="Century Gothic"/>
+                <a:cs typeface="Segoe UI"/>
               </a:rPr>
               <a:t>Charged Off</a:t>
             </a:r>
@@ -4105,8 +4222,10 @@
             <a:r>
               <a:rPr sz="2000" b="1" i="0">
                 <a:solidFill>
-                  <a:srgbClr val="424242"/>
-                </a:solidFill>
+                  <a:srgbClr val="3B82F6"/>
+                </a:solidFill>
+                <a:latin typeface="Century Gothic"/>
+                <a:cs typeface="Segoe UI Semibold"/>
               </a:rPr>
               <a:t>362,548  (19.5%)</a:t>
             </a:r>
@@ -4128,7 +4247,7 @@
             <a:avLst/>
           </a:prstGeom>
           <a:solidFill>
-            <a:srgbClr val="F5F5F5"/>
+            <a:srgbClr val="E2E8F0"/>
           </a:solidFill>
           <a:ln>
             <a:noFill/>
@@ -4153,6 +4272,7 @@
           <a:lstStyle/>
           <a:p>
             <a:pPr algn="ctr"/>
+            <a:endParaRPr/>
           </a:p>
         </p:txBody>
       </p:sp>
@@ -4182,8 +4302,10 @@
             <a:r>
               <a:rPr sz="1400" b="0" i="0">
                 <a:solidFill>
-                  <a:srgbClr val="757575"/>
-                </a:solidFill>
+                  <a:srgbClr val="64748B"/>
+                </a:solidFill>
+                <a:latin typeface="Century Gothic"/>
+                <a:cs typeface="Segoe UI"/>
               </a:rPr>
               <a:t>Date range</a:t>
             </a:r>
@@ -4216,8 +4338,10 @@
             <a:r>
               <a:rPr sz="2000" b="1" i="0">
                 <a:solidFill>
-                  <a:srgbClr val="424242"/>
-                </a:solidFill>
+                  <a:srgbClr val="0A0E27"/>
+                </a:solidFill>
+                <a:latin typeface="Century Gothic"/>
+                <a:cs typeface="Segoe UI Semibold"/>
               </a:rPr>
               <a:t>Jan 2007 – Sep 2020</a:t>
             </a:r>
@@ -4239,7 +4363,7 @@
             <a:avLst/>
           </a:prstGeom>
           <a:solidFill>
-            <a:srgbClr val="F5F5F5"/>
+            <a:srgbClr val="E2E8F0"/>
           </a:solidFill>
           <a:ln>
             <a:noFill/>
@@ -4264,6 +4388,7 @@
           <a:lstStyle/>
           <a:p>
             <a:pPr algn="ctr"/>
+            <a:endParaRPr/>
           </a:p>
         </p:txBody>
       </p:sp>
@@ -4291,10 +4416,12 @@
           <a:p>
             <a:pPr algn="l"/>
             <a:r>
-              <a:rPr sz="1100" b="0" i="1">
-                <a:solidFill>
-                  <a:srgbClr val="909090"/>
-                </a:solidFill>
+              <a:rPr sz="1400" b="0" i="1">
+                <a:solidFill>
+                  <a:srgbClr val="94A3B8"/>
+                </a:solidFill>
+                <a:latin typeface="Century Gothic"/>
+                <a:cs typeface="Segoe UI"/>
               </a:rPr>
               <a:t>Methodology: Only loans with a known outcome are included. In-progress loans (Current, Late, Grace Period) are excluded. All features used are observable at origination — no post-loan data.</a:t>
             </a:r>
@@ -4310,7 +4437,7 @@
 </file>
 
 <file path=ppt/slides/slide4.xml><?xml version="1.0" encoding="utf-8"?>
-<p:sld xmlns:a="http://schemas.openxmlformats.org/drawingml/2006/main" xmlns:p="http://schemas.openxmlformats.org/presentationml/2006/main" xmlns:r="http://schemas.openxmlformats.org/officeDocument/2006/relationships">
+<p:sld xmlns:a="http://schemas.openxmlformats.org/drawingml/2006/main" xmlns:r="http://schemas.openxmlformats.org/officeDocument/2006/relationships" xmlns:p="http://schemas.openxmlformats.org/presentationml/2006/main">
   <p:cSld>
     <p:spTree>
       <p:nvGrpSpPr>
@@ -4318,7 +4445,14 @@
         <p:cNvGrpSpPr/>
         <p:nvPr/>
       </p:nvGrpSpPr>
-      <p:grpSpPr/>
+      <p:grpSpPr>
+        <a:xfrm>
+          <a:off x="0" y="0"/>
+          <a:ext cx="0" cy="0"/>
+          <a:chOff x="0" y="0"/>
+          <a:chExt cx="0" cy="0"/>
+        </a:xfrm>
+      </p:grpSpPr>
       <p:sp>
         <p:nvSpPr>
           <p:cNvPr id="2" name="Rectangle 1"/>
@@ -4328,16 +4462,17 @@
         <p:spPr>
           <a:xfrm>
             <a:off x="0" y="0"/>
-            <a:ext cx="12191695" cy="1005840"/>
+            <a:ext cx="12192000" cy="6858000"/>
           </a:xfrm>
           <a:prstGeom prst="rect">
             <a:avLst/>
           </a:prstGeom>
           <a:solidFill>
-            <a:srgbClr val="0D47A1"/>
+            <a:srgbClr val="F9FAFB"/>
           </a:solidFill>
-          <a:ln>
+          <a:ln w="9525" cap="flat" cmpd="sng" algn="ctr">
             <a:noFill/>
+            <a:prstDash val="solid"/>
           </a:ln>
         </p:spPr>
         <p:style>
@@ -4359,6 +4494,7 @@
           <a:lstStyle/>
           <a:p>
             <a:pPr algn="ctr"/>
+            <a:endParaRPr/>
           </a:p>
         </p:txBody>
       </p:sp>
@@ -4370,8 +4506,8 @@
         </p:nvSpPr>
         <p:spPr>
           <a:xfrm>
-            <a:off x="320040" y="91440"/>
-            <a:ext cx="11521440" cy="777240"/>
+            <a:off x="317500" y="254000"/>
+            <a:ext cx="11518900" cy="635000"/>
           </a:xfrm>
           <a:prstGeom prst="rect">
             <a:avLst/>
@@ -4385,10 +4521,12 @@
           <a:lstStyle/>
           <a:p>
             <a:r>
-              <a:rPr b="1" sz="2700">
-                <a:solidFill>
-                  <a:srgbClr val="FFFFFF"/>
-                </a:solidFill>
+              <a:rPr sz="2200" b="1">
+                <a:solidFill>
+                  <a:srgbClr val="0A0E27"/>
+                </a:solidFill>
+                <a:latin typeface="Century Gothic"/>
+                <a:cs typeface="Segoe UI Semibold"/>
               </a:rPr>
               <a:t>Four Attributes Predict Default Before the Loan Is Made</a:t>
             </a:r>
@@ -4397,7 +4535,7 @@
       </p:sp>
       <p:pic>
         <p:nvPicPr>
-          <p:cNvPr id="4" name="Picture 3" descr="risk_by_fico.png"/>
+          <p:cNvPr id="4" name="Picture 3" descr="bad_rate_by_fico.png"/>
           <p:cNvPicPr>
             <a:picLocks noChangeAspect="1"/>
           </p:cNvPicPr>
@@ -4421,7 +4559,7 @@
       </p:pic>
       <p:pic>
         <p:nvPicPr>
-          <p:cNvPr id="5" name="Picture 4" descr="risk_by_grade.png"/>
+          <p:cNvPr id="5" name="Picture 4" descr="bad_rate_by_grade.png"/>
           <p:cNvPicPr>
             <a:picLocks noChangeAspect="1"/>
           </p:cNvPicPr>
@@ -4445,7 +4583,7 @@
       </p:pic>
       <p:pic>
         <p:nvPicPr>
-          <p:cNvPr id="6" name="Picture 5" descr="risk_by_revol_util.png"/>
+          <p:cNvPr id="6" name="Picture 5" descr="bad_rate_by_revol_util.png"/>
           <p:cNvPicPr>
             <a:picLocks noChangeAspect="1"/>
           </p:cNvPicPr>
@@ -4469,7 +4607,7 @@
       </p:pic>
       <p:pic>
         <p:nvPicPr>
-          <p:cNvPr id="7" name="Picture 6" descr="risk_by_purpose.png"/>
+          <p:cNvPr id="7" name="Picture 6" descr="bad_rate_by_purpose.png"/>
           <p:cNvPicPr>
             <a:picLocks noChangeAspect="1"/>
           </p:cNvPicPr>
@@ -4500,7 +4638,7 @@
 </file>
 
 <file path=ppt/slides/slide5.xml><?xml version="1.0" encoding="utf-8"?>
-<p:sld xmlns:a="http://schemas.openxmlformats.org/drawingml/2006/main" xmlns:p="http://schemas.openxmlformats.org/presentationml/2006/main" xmlns:r="http://schemas.openxmlformats.org/officeDocument/2006/relationships">
+<p:sld xmlns:a="http://schemas.openxmlformats.org/drawingml/2006/main" xmlns:r="http://schemas.openxmlformats.org/officeDocument/2006/relationships" xmlns:p="http://schemas.openxmlformats.org/presentationml/2006/main">
   <p:cSld>
     <p:spTree>
       <p:nvGrpSpPr>
@@ -4508,7 +4646,14 @@
         <p:cNvGrpSpPr/>
         <p:nvPr/>
       </p:nvGrpSpPr>
-      <p:grpSpPr/>
+      <p:grpSpPr>
+        <a:xfrm>
+          <a:off x="0" y="0"/>
+          <a:ext cx="0" cy="0"/>
+          <a:chOff x="0" y="0"/>
+          <a:chExt cx="0" cy="0"/>
+        </a:xfrm>
+      </p:grpSpPr>
       <p:sp>
         <p:nvSpPr>
           <p:cNvPr id="2" name="Rectangle 1"/>
@@ -4518,16 +4663,17 @@
         <p:spPr>
           <a:xfrm>
             <a:off x="0" y="0"/>
-            <a:ext cx="12191695" cy="1005840"/>
+            <a:ext cx="12192000" cy="6858000"/>
           </a:xfrm>
           <a:prstGeom prst="rect">
             <a:avLst/>
           </a:prstGeom>
           <a:solidFill>
-            <a:srgbClr val="0D47A1"/>
+            <a:srgbClr val="F9FAFB"/>
           </a:solidFill>
-          <a:ln>
+          <a:ln w="9525" cap="flat" cmpd="sng" algn="ctr">
             <a:noFill/>
+            <a:prstDash val="solid"/>
           </a:ln>
         </p:spPr>
         <p:style>
@@ -4549,6 +4695,7 @@
           <a:lstStyle/>
           <a:p>
             <a:pPr algn="ctr"/>
+            <a:endParaRPr/>
           </a:p>
         </p:txBody>
       </p:sp>
@@ -4560,8 +4707,8 @@
         </p:nvSpPr>
         <p:spPr>
           <a:xfrm>
-            <a:off x="320040" y="91440"/>
-            <a:ext cx="11521440" cy="777240"/>
+            <a:off x="317500" y="254000"/>
+            <a:ext cx="5593198" cy="646331"/>
           </a:xfrm>
           <a:prstGeom prst="rect">
             <a:avLst/>
@@ -4575,684 +4722,108 @@
           <a:lstStyle/>
           <a:p>
             <a:r>
-              <a:rPr b="1" sz="2700">
-                <a:solidFill>
-                  <a:srgbClr val="FFFFFF"/>
-                </a:solidFill>
+              <a:rPr sz="2200" b="1" dirty="0">
+                <a:solidFill>
+                  <a:srgbClr val="0A0E27"/>
+                </a:solidFill>
+                <a:latin typeface="Century Gothic"/>
+                <a:cs typeface="Segoe UI"/>
               </a:rPr>
-              <a:t>Six Evidence-Based Decline Rules</a:t>
-            </a:r>
-          </a:p>
-        </p:txBody>
-      </p:sp>
-      <p:graphicFrame>
-        <p:nvGraphicFramePr>
-          <p:cNvPr id="4" name="Table 3"/>
-          <p:cNvGraphicFramePr>
-            <a:graphicFrameLocks noGrp="1"/>
-          </p:cNvGraphicFramePr>
-          <p:nvPr/>
-        </p:nvGraphicFramePr>
-        <p:xfrm>
-          <a:off x="274320" y="1143000"/>
-          <a:ext cx="11612880" cy="5303520"/>
-        </p:xfrm>
-        <a:graphic>
-          <a:graphicData uri="http://schemas.openxmlformats.org/drawingml/2006/table">
-            <a:tbl>
-              <a:tblPr firstRow="1" bandRow="1">
-                <a:tableStyleId>{5C22544A-7EE6-4342-B048-85BDC9FD1C3A}</a:tableStyleId>
-              </a:tblPr>
-              <a:tblGrid>
-                <a:gridCol w="1920240"/>
-                <a:gridCol w="2103120"/>
-                <a:gridCol w="2103120"/>
-                <a:gridCol w="5486400"/>
-              </a:tblGrid>
-              <a:tr h="757645">
-                <a:tc>
-                  <a:txBody>
-                    <a:bodyPr wrap="square"/>
-                    <a:lstStyle/>
-                    <a:p>
-                      <a:pPr algn="ctr"/>
-                      <a:r>
-                        <a:rPr sz="1400" b="1">
-                          <a:solidFill>
-                            <a:srgbClr val="FFFFFF"/>
-                          </a:solidFill>
-                        </a:rPr>
-                        <a:t>Rule</a:t>
-                      </a:r>
-                    </a:p>
-                  </a:txBody>
-                  <a:tcPr>
-                    <a:solidFill>
-                      <a:srgbClr val="0D47A1"/>
-                    </a:solidFill>
-                  </a:tcPr>
-                </a:tc>
-                <a:tc>
-                  <a:txBody>
-                    <a:bodyPr wrap="square"/>
-                    <a:lstStyle/>
-                    <a:p>
-                      <a:pPr algn="ctr"/>
-                      <a:r>
-                        <a:rPr sz="1400" b="1">
-                          <a:solidFill>
-                            <a:srgbClr val="FFFFFF"/>
-                          </a:solidFill>
-                        </a:rPr>
-                        <a:t>Threshold</a:t>
-                      </a:r>
-                    </a:p>
-                  </a:txBody>
-                  <a:tcPr>
-                    <a:solidFill>
-                      <a:srgbClr val="0D47A1"/>
-                    </a:solidFill>
-                  </a:tcPr>
-                </a:tc>
-                <a:tc>
-                  <a:txBody>
-                    <a:bodyPr wrap="square"/>
-                    <a:lstStyle/>
-                    <a:p>
-                      <a:pPr algn="ctr"/>
-                      <a:r>
-                        <a:rPr sz="1400" b="1">
-                          <a:solidFill>
-                            <a:srgbClr val="FFFFFF"/>
-                          </a:solidFill>
-                        </a:rPr>
-                        <a:t>Bad Rate if Declined</a:t>
-                      </a:r>
-                    </a:p>
-                  </a:txBody>
-                  <a:tcPr>
-                    <a:solidFill>
-                      <a:srgbClr val="0D47A1"/>
-                    </a:solidFill>
-                  </a:tcPr>
-                </a:tc>
-                <a:tc>
-                  <a:txBody>
-                    <a:bodyPr wrap="square"/>
-                    <a:lstStyle/>
-                    <a:p>
-                      <a:pPr algn="ctr"/>
-                      <a:r>
-                        <a:rPr sz="1400" b="1">
-                          <a:solidFill>
-                            <a:srgbClr val="FFFFFF"/>
-                          </a:solidFill>
-                        </a:rPr>
-                        <a:t>Business Rationale</a:t>
-                      </a:r>
-                    </a:p>
-                  </a:txBody>
-                  <a:tcPr>
-                    <a:solidFill>
-                      <a:srgbClr val="0D47A1"/>
-                    </a:solidFill>
-                  </a:tcPr>
-                </a:tc>
-              </a:tr>
-              <a:tr h="757645">
-                <a:tc>
-                  <a:txBody>
-                    <a:bodyPr wrap="square"/>
-                    <a:lstStyle/>
-                    <a:p>
-                      <a:pPr algn="l"/>
-                      <a:r>
-                        <a:rPr sz="1300" b="1">
-                          <a:solidFill>
-                            <a:srgbClr val="424242"/>
-                          </a:solidFill>
-                        </a:rPr>
-                        <a:t>FICO Score</a:t>
-                      </a:r>
-                    </a:p>
-                  </a:txBody>
-                  <a:tcPr>
-                    <a:solidFill>
-                      <a:srgbClr val="FFFFFF"/>
-                    </a:solidFill>
-                  </a:tcPr>
-                </a:tc>
-                <a:tc>
-                  <a:txBody>
-                    <a:bodyPr wrap="square"/>
-                    <a:lstStyle/>
-                    <a:p>
-                      <a:pPr algn="l"/>
-                      <a:r>
-                        <a:rPr sz="1300" b="0">
-                          <a:solidFill>
-                            <a:srgbClr val="424242"/>
-                          </a:solidFill>
-                        </a:rPr>
-                        <a:t>&lt; 680</a:t>
-                      </a:r>
-                    </a:p>
-                  </a:txBody>
-                  <a:tcPr>
-                    <a:solidFill>
-                      <a:srgbClr val="FFFFFF"/>
-                    </a:solidFill>
-                  </a:tcPr>
-                </a:tc>
-                <a:tc>
-                  <a:txBody>
-                    <a:bodyPr wrap="square"/>
-                    <a:lstStyle/>
-                    <a:p>
-                      <a:pPr algn="l"/>
-                      <a:r>
-                        <a:rPr sz="1300" b="1">
-                          <a:solidFill>
-                            <a:srgbClr val="EF5350"/>
-                          </a:solidFill>
-                        </a:rPr>
-                        <a:t>24.4%</a:t>
-                      </a:r>
-                    </a:p>
-                  </a:txBody>
-                  <a:tcPr>
-                    <a:solidFill>
-                      <a:srgbClr val="FFFFFF"/>
-                    </a:solidFill>
-                  </a:tcPr>
-                </a:tc>
-                <a:tc>
-                  <a:txBody>
-                    <a:bodyPr wrap="square"/>
-                    <a:lstStyle/>
-                    <a:p>
-                      <a:pPr algn="l"/>
-                      <a:r>
-                        <a:rPr sz="1300" b="0">
-                          <a:solidFill>
-                            <a:srgbClr val="424242"/>
-                          </a:solidFill>
-                        </a:rPr>
-                        <a:t>Near-subprime; 2× the average default rate</a:t>
-                      </a:r>
-                    </a:p>
-                  </a:txBody>
-                  <a:tcPr>
-                    <a:solidFill>
-                      <a:srgbClr val="FFFFFF"/>
-                    </a:solidFill>
-                  </a:tcPr>
-                </a:tc>
-              </a:tr>
-              <a:tr h="757645">
-                <a:tc>
-                  <a:txBody>
-                    <a:bodyPr wrap="square"/>
-                    <a:lstStyle/>
-                    <a:p>
-                      <a:pPr algn="l"/>
-                      <a:r>
-                        <a:rPr sz="1300" b="1">
-                          <a:solidFill>
-                            <a:srgbClr val="424242"/>
-                          </a:solidFill>
-                        </a:rPr>
-                        <a:t>Loan Grade</a:t>
-                      </a:r>
-                    </a:p>
-                  </a:txBody>
-                  <a:tcPr>
-                    <a:solidFill>
-                      <a:srgbClr val="F5F5F5"/>
-                    </a:solidFill>
-                  </a:tcPr>
-                </a:tc>
-                <a:tc>
-                  <a:txBody>
-                    <a:bodyPr wrap="square"/>
-                    <a:lstStyle/>
-                    <a:p>
-                      <a:pPr algn="l"/>
-                      <a:r>
-                        <a:rPr sz="1300" b="0">
-                          <a:solidFill>
-                            <a:srgbClr val="424242"/>
-                          </a:solidFill>
-                        </a:rPr>
-                        <a:t>E, F, or G</a:t>
-                      </a:r>
-                    </a:p>
-                  </a:txBody>
-                  <a:tcPr>
-                    <a:solidFill>
-                      <a:srgbClr val="F5F5F5"/>
-                    </a:solidFill>
-                  </a:tcPr>
-                </a:tc>
-                <a:tc>
-                  <a:txBody>
-                    <a:bodyPr wrap="square"/>
-                    <a:lstStyle/>
-                    <a:p>
-                      <a:pPr algn="l"/>
-                      <a:r>
-                        <a:rPr sz="1300" b="1">
-                          <a:solidFill>
-                            <a:srgbClr val="EF5350"/>
-                          </a:solidFill>
-                        </a:rPr>
-                        <a:t>39.9%</a:t>
-                      </a:r>
-                    </a:p>
-                  </a:txBody>
-                  <a:tcPr>
-                    <a:solidFill>
-                      <a:srgbClr val="F5F5F5"/>
-                    </a:solidFill>
-                  </a:tcPr>
-                </a:tc>
-                <a:tc>
-                  <a:txBody>
-                    <a:bodyPr wrap="square"/>
-                    <a:lstStyle/>
-                    <a:p>
-                      <a:pPr algn="l"/>
-                      <a:r>
-                        <a:rPr sz="1300" b="0">
-                          <a:solidFill>
-                            <a:srgbClr val="424242"/>
-                          </a:solidFill>
-                        </a:rPr>
-                        <a:t>Lending Club's own model flags &gt;28% expected default</a:t>
-                      </a:r>
-                    </a:p>
-                  </a:txBody>
-                  <a:tcPr>
-                    <a:solidFill>
-                      <a:srgbClr val="F5F5F5"/>
-                    </a:solidFill>
-                  </a:tcPr>
-                </a:tc>
-              </a:tr>
-              <a:tr h="757645">
-                <a:tc>
-                  <a:txBody>
-                    <a:bodyPr wrap="square"/>
-                    <a:lstStyle/>
-                    <a:p>
-                      <a:pPr algn="l"/>
-                      <a:r>
-                        <a:rPr sz="1300" b="1">
-                          <a:solidFill>
-                            <a:srgbClr val="424242"/>
-                          </a:solidFill>
-                        </a:rPr>
-                        <a:t>Revolving Util</a:t>
-                      </a:r>
-                    </a:p>
-                  </a:txBody>
-                  <a:tcPr>
-                    <a:solidFill>
-                      <a:srgbClr val="FFFFFF"/>
-                    </a:solidFill>
-                  </a:tcPr>
-                </a:tc>
-                <a:tc>
-                  <a:txBody>
-                    <a:bodyPr wrap="square"/>
-                    <a:lstStyle/>
-                    <a:p>
-                      <a:pPr algn="l"/>
-                      <a:r>
-                        <a:rPr sz="1300" b="0">
-                          <a:solidFill>
-                            <a:srgbClr val="424242"/>
-                          </a:solidFill>
-                        </a:rPr>
-                        <a:t>&gt; 80%</a:t>
-                      </a:r>
-                    </a:p>
-                  </a:txBody>
-                  <a:tcPr>
-                    <a:solidFill>
-                      <a:srgbClr val="FFFFFF"/>
-                    </a:solidFill>
-                  </a:tcPr>
-                </a:tc>
-                <a:tc>
-                  <a:txBody>
-                    <a:bodyPr wrap="square"/>
-                    <a:lstStyle/>
-                    <a:p>
-                      <a:pPr algn="l"/>
-                      <a:r>
-                        <a:rPr sz="1300" b="1">
-                          <a:solidFill>
-                            <a:srgbClr val="EF5350"/>
-                          </a:solidFill>
-                        </a:rPr>
-                        <a:t>21.6%</a:t>
-                      </a:r>
-                    </a:p>
-                  </a:txBody>
-                  <a:tcPr>
-                    <a:solidFill>
-                      <a:srgbClr val="FFFFFF"/>
-                    </a:solidFill>
-                  </a:tcPr>
-                </a:tc>
-                <a:tc>
-                  <a:txBody>
-                    <a:bodyPr wrap="square"/>
-                    <a:lstStyle/>
-                    <a:p>
-                      <a:pPr algn="l"/>
-                      <a:r>
-                        <a:rPr sz="1300" b="0">
-                          <a:solidFill>
-                            <a:srgbClr val="424242"/>
-                          </a:solidFill>
-                        </a:rPr>
-                        <a:t>Maxed-out credit = severe financial stress</a:t>
-                      </a:r>
-                    </a:p>
-                  </a:txBody>
-                  <a:tcPr>
-                    <a:solidFill>
-                      <a:srgbClr val="FFFFFF"/>
-                    </a:solidFill>
-                  </a:tcPr>
-                </a:tc>
-              </a:tr>
-              <a:tr h="757645">
-                <a:tc>
-                  <a:txBody>
-                    <a:bodyPr wrap="square"/>
-                    <a:lstStyle/>
-                    <a:p>
-                      <a:pPr algn="l"/>
-                      <a:r>
-                        <a:rPr sz="1300" b="1">
-                          <a:solidFill>
-                            <a:srgbClr val="424242"/>
-                          </a:solidFill>
-                        </a:rPr>
-                        <a:t>Bankruptcy</a:t>
-                      </a:r>
-                    </a:p>
-                  </a:txBody>
-                  <a:tcPr>
-                    <a:solidFill>
-                      <a:srgbClr val="F5F5F5"/>
-                    </a:solidFill>
-                  </a:tcPr>
-                </a:tc>
-                <a:tc>
-                  <a:txBody>
-                    <a:bodyPr wrap="square"/>
-                    <a:lstStyle/>
-                    <a:p>
-                      <a:pPr algn="l"/>
-                      <a:r>
-                        <a:rPr sz="1300" b="0">
-                          <a:solidFill>
-                            <a:srgbClr val="424242"/>
-                          </a:solidFill>
-                        </a:rPr>
-                        <a:t>Any record</a:t>
-                      </a:r>
-                    </a:p>
-                  </a:txBody>
-                  <a:tcPr>
-                    <a:solidFill>
-                      <a:srgbClr val="F5F5F5"/>
-                    </a:solidFill>
-                  </a:tcPr>
-                </a:tc>
-                <a:tc>
-                  <a:txBody>
-                    <a:bodyPr wrap="square"/>
-                    <a:lstStyle/>
-                    <a:p>
-                      <a:pPr algn="l"/>
-                      <a:r>
-                        <a:rPr sz="1300" b="1">
-                          <a:solidFill>
-                            <a:srgbClr val="EF5350"/>
-                          </a:solidFill>
-                        </a:rPr>
-                        <a:t>22.5%</a:t>
-                      </a:r>
-                    </a:p>
-                  </a:txBody>
-                  <a:tcPr>
-                    <a:solidFill>
-                      <a:srgbClr val="F5F5F5"/>
-                    </a:solidFill>
-                  </a:tcPr>
-                </a:tc>
-                <a:tc>
-                  <a:txBody>
-                    <a:bodyPr wrap="square"/>
-                    <a:lstStyle/>
-                    <a:p>
-                      <a:pPr algn="l"/>
-                      <a:r>
-                        <a:rPr sz="1300" b="0">
-                          <a:solidFill>
-                            <a:srgbClr val="424242"/>
-                          </a:solidFill>
-                        </a:rPr>
-                        <a:t>Prior bankruptcy = proven inability to repay</a:t>
-                      </a:r>
-                    </a:p>
-                  </a:txBody>
-                  <a:tcPr>
-                    <a:solidFill>
-                      <a:srgbClr val="F5F5F5"/>
-                    </a:solidFill>
-                  </a:tcPr>
-                </a:tc>
-              </a:tr>
-              <a:tr h="757645">
-                <a:tc>
-                  <a:txBody>
-                    <a:bodyPr wrap="square"/>
-                    <a:lstStyle/>
-                    <a:p>
-                      <a:pPr algn="l"/>
-                      <a:r>
-                        <a:rPr sz="1300" b="1">
-                          <a:solidFill>
-                            <a:srgbClr val="424242"/>
-                          </a:solidFill>
-                        </a:rPr>
-                        <a:t>Credit Inquiries</a:t>
-                      </a:r>
-                    </a:p>
-                  </a:txBody>
-                  <a:tcPr>
-                    <a:solidFill>
-                      <a:srgbClr val="FFFFFF"/>
-                    </a:solidFill>
-                  </a:tcPr>
-                </a:tc>
-                <a:tc>
-                  <a:txBody>
-                    <a:bodyPr wrap="square"/>
-                    <a:lstStyle/>
-                    <a:p>
-                      <a:pPr algn="l"/>
-                      <a:r>
-                        <a:rPr sz="1300" b="0">
-                          <a:solidFill>
-                            <a:srgbClr val="424242"/>
-                          </a:solidFill>
-                        </a:rPr>
-                        <a:t>≥ 4 in last 6 mo</a:t>
-                      </a:r>
-                    </a:p>
-                  </a:txBody>
-                  <a:tcPr>
-                    <a:solidFill>
-                      <a:srgbClr val="FFFFFF"/>
-                    </a:solidFill>
-                  </a:tcPr>
-                </a:tc>
-                <a:tc>
-                  <a:txBody>
-                    <a:bodyPr wrap="square"/>
-                    <a:lstStyle/>
-                    <a:p>
-                      <a:pPr algn="l"/>
-                      <a:r>
-                        <a:rPr sz="1300" b="1">
-                          <a:solidFill>
-                            <a:srgbClr val="EF5350"/>
-                          </a:solidFill>
-                        </a:rPr>
-                        <a:t>~27%</a:t>
-                      </a:r>
-                    </a:p>
-                  </a:txBody>
-                  <a:tcPr>
-                    <a:solidFill>
-                      <a:srgbClr val="FFFFFF"/>
-                    </a:solidFill>
-                  </a:tcPr>
-                </a:tc>
-                <a:tc>
-                  <a:txBody>
-                    <a:bodyPr wrap="square"/>
-                    <a:lstStyle/>
-                    <a:p>
-                      <a:pPr algn="l"/>
-                      <a:r>
-                        <a:rPr sz="1300" b="0">
-                          <a:solidFill>
-                            <a:srgbClr val="424242"/>
-                          </a:solidFill>
-                        </a:rPr>
-                        <a:t>Rapid credit-seeking = financial desperation signal</a:t>
-                      </a:r>
-                    </a:p>
-                  </a:txBody>
-                  <a:tcPr>
-                    <a:solidFill>
-                      <a:srgbClr val="FFFFFF"/>
-                    </a:solidFill>
-                  </a:tcPr>
-                </a:tc>
-              </a:tr>
-              <a:tr h="757650">
-                <a:tc>
-                  <a:txBody>
-                    <a:bodyPr wrap="square"/>
-                    <a:lstStyle/>
-                    <a:p>
-                      <a:pPr algn="l"/>
-                      <a:r>
-                        <a:rPr sz="1300" b="1">
-                          <a:solidFill>
-                            <a:srgbClr val="424242"/>
-                          </a:solidFill>
-                        </a:rPr>
-                        <a:t>DTI</a:t>
-                      </a:r>
-                    </a:p>
-                  </a:txBody>
-                  <a:tcPr>
-                    <a:solidFill>
-                      <a:srgbClr val="F5F5F5"/>
-                    </a:solidFill>
-                  </a:tcPr>
-                </a:tc>
-                <a:tc>
-                  <a:txBody>
-                    <a:bodyPr wrap="square"/>
-                    <a:lstStyle/>
-                    <a:p>
-                      <a:pPr algn="l"/>
-                      <a:r>
-                        <a:rPr sz="1300" b="0">
-                          <a:solidFill>
-                            <a:srgbClr val="424242"/>
-                          </a:solidFill>
-                        </a:rPr>
-                        <a:t>&gt; 35%</a:t>
-                      </a:r>
-                    </a:p>
-                  </a:txBody>
-                  <a:tcPr>
-                    <a:solidFill>
-                      <a:srgbClr val="F5F5F5"/>
-                    </a:solidFill>
-                  </a:tcPr>
-                </a:tc>
-                <a:tc>
-                  <a:txBody>
-                    <a:bodyPr wrap="square"/>
-                    <a:lstStyle/>
-                    <a:p>
-                      <a:pPr algn="l"/>
-                      <a:r>
-                        <a:rPr sz="1300" b="1">
-                          <a:solidFill>
-                            <a:srgbClr val="EF5350"/>
-                          </a:solidFill>
-                        </a:rPr>
-                        <a:t>~29%</a:t>
-                      </a:r>
-                    </a:p>
-                  </a:txBody>
-                  <a:tcPr>
-                    <a:solidFill>
-                      <a:srgbClr val="F5F5F5"/>
-                    </a:solidFill>
-                  </a:tcPr>
-                </a:tc>
-                <a:tc>
-                  <a:txBody>
-                    <a:bodyPr wrap="square"/>
-                    <a:lstStyle/>
-                    <a:p>
-                      <a:pPr algn="l"/>
-                      <a:r>
-                        <a:rPr sz="1300" b="0">
-                          <a:solidFill>
-                            <a:srgbClr val="424242"/>
-                          </a:solidFill>
-                        </a:rPr>
-                        <a:t>Monthly debt burden exceeds safe capacity threshold</a:t>
-                      </a:r>
-                    </a:p>
-                  </a:txBody>
-                  <a:tcPr>
-                    <a:solidFill>
-                      <a:srgbClr val="F5F5F5"/>
-                    </a:solidFill>
-                  </a:tcPr>
-                </a:tc>
-              </a:tr>
-            </a:tbl>
-          </a:graphicData>
-        </a:graphic>
-      </p:graphicFrame>
-      <p:sp>
-        <p:nvSpPr>
-          <p:cNvPr id="5" name="TextBox 4"/>
+              <a:t>Risk Compounds: FICO × DTI Interaction</a:t>
+            </a:r>
+          </a:p>
+          <a:p>
+            <a:r>
+              <a:rPr sz="1400" b="1" dirty="0">
+                <a:solidFill>
+                  <a:srgbClr val="0A0E27"/>
+                </a:solidFill>
+                <a:latin typeface="Century Gothic"/>
+                <a:cs typeface="Segoe UI"/>
+              </a:rPr>
+              <a:t>Low FICO + High DTI = the worst borrower pocket</a:t>
+            </a:r>
+          </a:p>
+        </p:txBody>
+      </p:sp>
+      <p:pic>
+        <p:nvPicPr>
+          <p:cNvPr id="4" name="Picture 3" descr="heatmap_fico_dti.png"/>
+          <p:cNvPicPr>
+            <a:picLocks noChangeAspect="1"/>
+          </p:cNvPicPr>
+          <p:nvPr/>
+        </p:nvPicPr>
+        <p:blipFill>
+          <a:blip r:embed="rId2"/>
+          <a:stretch>
+            <a:fillRect/>
+          </a:stretch>
+        </p:blipFill>
+        <p:spPr>
+          <a:xfrm>
+            <a:off x="182880" y="1143000"/>
+            <a:ext cx="11887200" cy="4389120"/>
+          </a:xfrm>
+          <a:prstGeom prst="rect">
+            <a:avLst/>
+          </a:prstGeom>
+        </p:spPr>
+      </p:pic>
+      <p:sp>
+        <p:nvSpPr>
+          <p:cNvPr id="5" name="Rectangle 4"/>
+          <p:cNvSpPr/>
+          <p:nvPr/>
+        </p:nvSpPr>
+        <p:spPr>
+          <a:xfrm>
+            <a:off x="274320" y="5669280"/>
+            <a:ext cx="7772400" cy="822960"/>
+          </a:xfrm>
+          <a:prstGeom prst="rect">
+            <a:avLst/>
+          </a:prstGeom>
+          <a:solidFill>
+            <a:srgbClr val="EFF6FF"/>
+          </a:solidFill>
+          <a:ln>
+            <a:noFill/>
+          </a:ln>
+        </p:spPr>
+        <p:style>
+          <a:lnRef idx="1">
+            <a:schemeClr val="accent1"/>
+          </a:lnRef>
+          <a:fillRef idx="3">
+            <a:schemeClr val="accent1"/>
+          </a:fillRef>
+          <a:effectRef idx="2">
+            <a:schemeClr val="accent1"/>
+          </a:effectRef>
+          <a:fontRef idx="minor">
+            <a:schemeClr val="lt1"/>
+          </a:fontRef>
+        </p:style>
+        <p:txBody>
+          <a:bodyPr rtlCol="0" anchor="ctr"/>
+          <a:lstStyle/>
+          <a:p>
+            <a:pPr algn="ctr"/>
+            <a:endParaRPr/>
+          </a:p>
+        </p:txBody>
+      </p:sp>
+      <p:sp>
+        <p:nvSpPr>
+          <p:cNvPr id="6" name="TextBox 5"/>
           <p:cNvSpPr txBox="1"/>
           <p:nvPr/>
         </p:nvSpPr>
         <p:spPr>
           <a:xfrm>
-            <a:off x="274320" y="6492240"/>
-            <a:ext cx="9144000" cy="292608"/>
+            <a:off x="365760" y="5715000"/>
+            <a:ext cx="7589520" cy="749808"/>
           </a:xfrm>
           <a:prstGeom prst="rect">
             <a:avLst/>
@@ -5267,12 +4838,52 @@
           <a:p>
             <a:pPr algn="l"/>
             <a:r>
-              <a:rPr sz="1100" b="0" i="1">
-                <a:solidFill>
-                  <a:srgbClr val="909090"/>
-                </a:solidFill>
+              <a:rPr sz="1300" b="0" i="0">
+                <a:solidFill>
+                  <a:srgbClr val="0A0E27"/>
+                </a:solidFill>
+                <a:latin typeface="Century Gothic"/>
+                <a:cs typeface="Segoe UI"/>
               </a:rPr>
-              <a:t>Baseline bad rate: 19.5%  ·  All rules use only origination-time data</a:t>
+              <a:t>Borrowers with FICO &lt; 680 AND DTI &gt; 35% default at the highest rate — nearly 2–3× the portfolio average. The right panel confirms this is a large enough segment to matter commercially.</a:t>
+            </a:r>
+          </a:p>
+        </p:txBody>
+      </p:sp>
+      <p:sp>
+        <p:nvSpPr>
+          <p:cNvPr id="7" name="TextBox 6"/>
+          <p:cNvSpPr txBox="1"/>
+          <p:nvPr/>
+        </p:nvSpPr>
+        <p:spPr>
+          <a:xfrm>
+            <a:off x="8321040" y="5669280"/>
+            <a:ext cx="3657600" cy="914400"/>
+          </a:xfrm>
+          <a:prstGeom prst="rect">
+            <a:avLst/>
+          </a:prstGeom>
+          <a:noFill/>
+        </p:spPr>
+        <p:txBody>
+          <a:bodyPr wrap="square">
+            <a:spAutoFit/>
+          </a:bodyPr>
+          <a:lstStyle/>
+          <a:p>
+            <a:pPr algn="l"/>
+            <a:r>
+              <a:rPr sz="1400" b="1" i="0">
+                <a:solidFill>
+                  <a:srgbClr val="3B82F6"/>
+                </a:solidFill>
+                <a:latin typeface="Century Gothic"/>
+                <a:cs typeface="Segoe UI Semibold"/>
+              </a:rPr>
+              <a:t>Variables compound:
+risk is not additive —
+it multiplies.</a:t>
             </a:r>
           </a:p>
         </p:txBody>
@@ -5286,7 +4897,7 @@
 </file>
 
 <file path=ppt/slides/slide6.xml><?xml version="1.0" encoding="utf-8"?>
-<p:sld xmlns:a="http://schemas.openxmlformats.org/drawingml/2006/main" xmlns:p="http://schemas.openxmlformats.org/presentationml/2006/main" xmlns:r="http://schemas.openxmlformats.org/officeDocument/2006/relationships">
+<p:sld xmlns:a="http://schemas.openxmlformats.org/drawingml/2006/main" xmlns:r="http://schemas.openxmlformats.org/officeDocument/2006/relationships" xmlns:p="http://schemas.openxmlformats.org/presentationml/2006/main">
   <p:cSld>
     <p:spTree>
       <p:nvGrpSpPr>
@@ -5294,7 +4905,14 @@
         <p:cNvGrpSpPr/>
         <p:nvPr/>
       </p:nvGrpSpPr>
-      <p:grpSpPr/>
+      <p:grpSpPr>
+        <a:xfrm>
+          <a:off x="0" y="0"/>
+          <a:ext cx="0" cy="0"/>
+          <a:chOff x="0" y="0"/>
+          <a:chExt cx="0" cy="0"/>
+        </a:xfrm>
+      </p:grpSpPr>
       <p:sp>
         <p:nvSpPr>
           <p:cNvPr id="2" name="Rectangle 1"/>
@@ -5304,16 +4922,17 @@
         <p:spPr>
           <a:xfrm>
             <a:off x="0" y="0"/>
-            <a:ext cx="12191695" cy="1005840"/>
+            <a:ext cx="12192000" cy="6858000"/>
           </a:xfrm>
           <a:prstGeom prst="rect">
             <a:avLst/>
           </a:prstGeom>
           <a:solidFill>
-            <a:srgbClr val="0D47A1"/>
+            <a:srgbClr val="F9FAFB"/>
           </a:solidFill>
-          <a:ln>
+          <a:ln w="9525" cap="flat" cmpd="sng" algn="ctr">
             <a:noFill/>
+            <a:prstDash val="solid"/>
           </a:ln>
         </p:spPr>
         <p:style>
@@ -5335,6 +4954,7 @@
           <a:lstStyle/>
           <a:p>
             <a:pPr algn="ctr"/>
+            <a:endParaRPr/>
           </a:p>
         </p:txBody>
       </p:sp>
@@ -5346,8 +4966,8 @@
         </p:nvSpPr>
         <p:spPr>
           <a:xfrm>
-            <a:off x="320040" y="91440"/>
-            <a:ext cx="11521440" cy="777240"/>
+            <a:off x="317500" y="254000"/>
+            <a:ext cx="11518900" cy="635000"/>
           </a:xfrm>
           <a:prstGeom prst="rect">
             <a:avLst/>
@@ -5361,19 +4981,63 @@
           <a:lstStyle/>
           <a:p>
             <a:r>
-              <a:rPr b="1" sz="2700">
-                <a:solidFill>
-                  <a:srgbClr val="FFFFFF"/>
-                </a:solidFill>
+              <a:rPr sz="2200" b="1">
+                <a:solidFill>
+                  <a:srgbClr val="0A0E27"/>
+                </a:solidFill>
+                <a:latin typeface="Century Gothic"/>
+                <a:cs typeface="Segoe UI Semibold"/>
               </a:rPr>
-              <a:t>Recommended Ruleset: FICO &lt; 680  OR  Grade E/F/G  OR  Revol Util &gt; 80%</a:t>
+              <a:t>Recommended Policy: Three Evidence-Based Decline Rules</a:t>
+            </a:r>
+          </a:p>
+        </p:txBody>
+      </p:sp>
+      <p:sp>
+        <p:nvSpPr>
+          <p:cNvPr id="7" name="TextBox 6"/>
+          <p:cNvSpPr txBox="1"/>
+          <p:nvPr/>
+        </p:nvSpPr>
+        <p:spPr>
+          <a:xfrm>
+            <a:off x="274320" y="6492240"/>
+            <a:ext cx="9144000" cy="292608"/>
+          </a:xfrm>
+          <a:prstGeom prst="rect">
+            <a:avLst/>
+          </a:prstGeom>
+          <a:noFill/>
+        </p:spPr>
+        <p:txBody>
+          <a:bodyPr wrap="square">
+            <a:spAutoFit/>
+          </a:bodyPr>
+          <a:lstStyle/>
+          <a:p>
+            <a:pPr algn="l"/>
+            <a:r>
+              <a:rPr sz="1400" b="0" i="1">
+                <a:solidFill>
+                  <a:srgbClr val="94A3B8"/>
+                </a:solidFill>
+                <a:latin typeface="Century Gothic"/>
+                <a:cs typeface="Segoe UI"/>
+              </a:rPr>
+              <a:t>Baseline bad rate: 19.5%  ·  All thresholds use only origination-time data</a:t>
             </a:r>
           </a:p>
         </p:txBody>
       </p:sp>
       <p:pic>
         <p:nvPicPr>
-          <p:cNvPr id="4" name="Picture 3" descr="tradeoff_scatter.png"/>
+          <p:cNvPr id="8" name="Picture 7">
+            <a:extLst>
+              <a:ext uri="{FF2B5EF4-FFF2-40B4-BE49-F238E27FC236}">
+                <a16:creationId xmlns:a16="http://schemas.microsoft.com/office/drawing/2014/main" id="{324DD381-3242-6DDB-316F-182BB4843649}"/>
+              </a:ext>
+            </a:extLst>
+          </p:cNvPr>
           <p:cNvPicPr>
             <a:picLocks noChangeAspect="1"/>
           </p:cNvPicPr>
@@ -5387,631 +5051,8 @@
         </p:blipFill>
         <p:spPr>
           <a:xfrm>
-            <a:off x="91440" y="1097280"/>
-            <a:ext cx="7132320" cy="5303520"/>
-          </a:xfrm>
-          <a:prstGeom prst="rect">
-            <a:avLst/>
-          </a:prstGeom>
-        </p:spPr>
-      </p:pic>
-      <p:sp>
-        <p:nvSpPr>
-          <p:cNvPr id="5" name="Rectangle 4"/>
-          <p:cNvSpPr/>
-          <p:nvPr/>
-        </p:nvSpPr>
-        <p:spPr>
-          <a:xfrm>
-            <a:off x="7498079" y="1234440"/>
-            <a:ext cx="4389120" cy="502920"/>
-          </a:xfrm>
-          <a:prstGeom prst="rect">
-            <a:avLst/>
-          </a:prstGeom>
-          <a:solidFill>
-            <a:srgbClr val="0D47A1"/>
-          </a:solidFill>
-          <a:ln>
-            <a:noFill/>
-          </a:ln>
-        </p:spPr>
-        <p:style>
-          <a:lnRef idx="1">
-            <a:schemeClr val="accent1"/>
-          </a:lnRef>
-          <a:fillRef idx="3">
-            <a:schemeClr val="accent1"/>
-          </a:fillRef>
-          <a:effectRef idx="2">
-            <a:schemeClr val="accent1"/>
-          </a:effectRef>
-          <a:fontRef idx="minor">
-            <a:schemeClr val="lt1"/>
-          </a:fontRef>
-        </p:style>
-        <p:txBody>
-          <a:bodyPr rtlCol="0" anchor="ctr"/>
-          <a:lstStyle/>
-          <a:p>
-            <a:pPr algn="ctr"/>
-          </a:p>
-        </p:txBody>
-      </p:sp>
-      <p:sp>
-        <p:nvSpPr>
-          <p:cNvPr id="6" name="TextBox 5"/>
-          <p:cNvSpPr txBox="1"/>
-          <p:nvPr/>
-        </p:nvSpPr>
-        <p:spPr>
-          <a:xfrm>
-            <a:off x="7498079" y="1234440"/>
-            <a:ext cx="4389120" cy="502920"/>
-          </a:xfrm>
-          <a:prstGeom prst="rect">
-            <a:avLst/>
-          </a:prstGeom>
-          <a:noFill/>
-        </p:spPr>
-        <p:txBody>
-          <a:bodyPr wrap="square">
-            <a:spAutoFit/>
-          </a:bodyPr>
-          <a:lstStyle/>
-          <a:p>
-            <a:pPr algn="l"/>
-            <a:r>
-              <a:rPr sz="1500" b="1" i="0">
-                <a:solidFill>
-                  <a:srgbClr val="FFFFFF"/>
-                </a:solidFill>
-              </a:rPr>
-              <a:t>  Recommended Ruleset (R4)</a:t>
-            </a:r>
-          </a:p>
-        </p:txBody>
-      </p:sp>
-      <p:sp>
-        <p:nvSpPr>
-          <p:cNvPr id="7" name="TextBox 6"/>
-          <p:cNvSpPr txBox="1"/>
-          <p:nvPr/>
-        </p:nvSpPr>
-        <p:spPr>
-          <a:xfrm>
-            <a:off x="7589520" y="1874519"/>
-            <a:ext cx="2926080" cy="320040"/>
-          </a:xfrm>
-          <a:prstGeom prst="rect">
-            <a:avLst/>
-          </a:prstGeom>
-          <a:noFill/>
-        </p:spPr>
-        <p:txBody>
-          <a:bodyPr wrap="square">
-            <a:spAutoFit/>
-          </a:bodyPr>
-          <a:lstStyle/>
-          <a:p>
-            <a:pPr algn="l"/>
-            <a:r>
-              <a:rPr sz="1300" b="0" i="0">
-                <a:solidFill>
-                  <a:srgbClr val="757575"/>
-                </a:solidFill>
-              </a:rPr>
-              <a:t>Volume Declined</a:t>
-            </a:r>
-          </a:p>
-        </p:txBody>
-      </p:sp>
-      <p:sp>
-        <p:nvSpPr>
-          <p:cNvPr id="8" name="TextBox 7"/>
-          <p:cNvSpPr txBox="1"/>
-          <p:nvPr/>
-        </p:nvSpPr>
-        <p:spPr>
-          <a:xfrm>
-            <a:off x="10058400" y="1874519"/>
-            <a:ext cx="1737360" cy="320040"/>
-          </a:xfrm>
-          <a:prstGeom prst="rect">
-            <a:avLst/>
-          </a:prstGeom>
-          <a:noFill/>
-        </p:spPr>
-        <p:txBody>
-          <a:bodyPr wrap="square">
-            <a:spAutoFit/>
-          </a:bodyPr>
-          <a:lstStyle/>
-          <a:p>
-            <a:pPr algn="r"/>
-            <a:r>
-              <a:rPr sz="1600" b="1" i="0">
-                <a:solidFill>
-                  <a:srgbClr val="424242"/>
-                </a:solidFill>
-              </a:rPr>
-              <a:t>43.3%</a:t>
-            </a:r>
-          </a:p>
-        </p:txBody>
-      </p:sp>
-      <p:sp>
-        <p:nvSpPr>
-          <p:cNvPr id="9" name="Rectangle 8"/>
-          <p:cNvSpPr/>
-          <p:nvPr/>
-        </p:nvSpPr>
-        <p:spPr>
-          <a:xfrm>
-            <a:off x="274320" y="2221991"/>
-            <a:ext cx="11612880" cy="18288"/>
-          </a:xfrm>
-          <a:prstGeom prst="rect">
-            <a:avLst/>
-          </a:prstGeom>
-          <a:solidFill>
-            <a:srgbClr val="F5F5F5"/>
-          </a:solidFill>
-          <a:ln>
-            <a:noFill/>
-          </a:ln>
-        </p:spPr>
-        <p:style>
-          <a:lnRef idx="1">
-            <a:schemeClr val="accent1"/>
-          </a:lnRef>
-          <a:fillRef idx="3">
-            <a:schemeClr val="accent1"/>
-          </a:fillRef>
-          <a:effectRef idx="2">
-            <a:schemeClr val="accent1"/>
-          </a:effectRef>
-          <a:fontRef idx="minor">
-            <a:schemeClr val="lt1"/>
-          </a:fontRef>
-        </p:style>
-        <p:txBody>
-          <a:bodyPr rtlCol="0" anchor="ctr"/>
-          <a:lstStyle/>
-          <a:p>
-            <a:pPr algn="ctr"/>
-          </a:p>
-        </p:txBody>
-      </p:sp>
-      <p:sp>
-        <p:nvSpPr>
-          <p:cNvPr id="10" name="TextBox 9"/>
-          <p:cNvSpPr txBox="1"/>
-          <p:nvPr/>
-        </p:nvSpPr>
-        <p:spPr>
-          <a:xfrm>
-            <a:off x="7589520" y="2441447"/>
-            <a:ext cx="2926080" cy="320040"/>
-          </a:xfrm>
-          <a:prstGeom prst="rect">
-            <a:avLst/>
-          </a:prstGeom>
-          <a:noFill/>
-        </p:spPr>
-        <p:txBody>
-          <a:bodyPr wrap="square">
-            <a:spAutoFit/>
-          </a:bodyPr>
-          <a:lstStyle/>
-          <a:p>
-            <a:pPr algn="l"/>
-            <a:r>
-              <a:rPr sz="1300" b="0" i="0">
-                <a:solidFill>
-                  <a:srgbClr val="757575"/>
-                </a:solidFill>
-              </a:rPr>
-              <a:t>New Bad Rate</a:t>
-            </a:r>
-          </a:p>
-        </p:txBody>
-      </p:sp>
-      <p:sp>
-        <p:nvSpPr>
-          <p:cNvPr id="11" name="TextBox 10"/>
-          <p:cNvSpPr txBox="1"/>
-          <p:nvPr/>
-        </p:nvSpPr>
-        <p:spPr>
-          <a:xfrm>
-            <a:off x="10058400" y="2441447"/>
-            <a:ext cx="1737360" cy="320040"/>
-          </a:xfrm>
-          <a:prstGeom prst="rect">
-            <a:avLst/>
-          </a:prstGeom>
-          <a:noFill/>
-        </p:spPr>
-        <p:txBody>
-          <a:bodyPr wrap="square">
-            <a:spAutoFit/>
-          </a:bodyPr>
-          <a:lstStyle/>
-          <a:p>
-            <a:pPr algn="r"/>
-            <a:r>
-              <a:rPr sz="1600" b="1" i="0">
-                <a:solidFill>
-                  <a:srgbClr val="2E7D32"/>
-                </a:solidFill>
-              </a:rPr>
-              <a:t>15.5%</a:t>
-            </a:r>
-          </a:p>
-        </p:txBody>
-      </p:sp>
-      <p:sp>
-        <p:nvSpPr>
-          <p:cNvPr id="12" name="Rectangle 11"/>
-          <p:cNvSpPr/>
-          <p:nvPr/>
-        </p:nvSpPr>
-        <p:spPr>
-          <a:xfrm>
-            <a:off x="274320" y="2788919"/>
-            <a:ext cx="11612880" cy="18288"/>
-          </a:xfrm>
-          <a:prstGeom prst="rect">
-            <a:avLst/>
-          </a:prstGeom>
-          <a:solidFill>
-            <a:srgbClr val="F5F5F5"/>
-          </a:solidFill>
-          <a:ln>
-            <a:noFill/>
-          </a:ln>
-        </p:spPr>
-        <p:style>
-          <a:lnRef idx="1">
-            <a:schemeClr val="accent1"/>
-          </a:lnRef>
-          <a:fillRef idx="3">
-            <a:schemeClr val="accent1"/>
-          </a:fillRef>
-          <a:effectRef idx="2">
-            <a:schemeClr val="accent1"/>
-          </a:effectRef>
-          <a:fontRef idx="minor">
-            <a:schemeClr val="lt1"/>
-          </a:fontRef>
-        </p:style>
-        <p:txBody>
-          <a:bodyPr rtlCol="0" anchor="ctr"/>
-          <a:lstStyle/>
-          <a:p>
-            <a:pPr algn="ctr"/>
-          </a:p>
-        </p:txBody>
-      </p:sp>
-      <p:sp>
-        <p:nvSpPr>
-          <p:cNvPr id="13" name="TextBox 12"/>
-          <p:cNvSpPr txBox="1"/>
-          <p:nvPr/>
-        </p:nvSpPr>
-        <p:spPr>
-          <a:xfrm>
-            <a:off x="7589520" y="3008375"/>
-            <a:ext cx="2926080" cy="320040"/>
-          </a:xfrm>
-          <a:prstGeom prst="rect">
-            <a:avLst/>
-          </a:prstGeom>
-          <a:noFill/>
-        </p:spPr>
-        <p:txBody>
-          <a:bodyPr wrap="square">
-            <a:spAutoFit/>
-          </a:bodyPr>
-          <a:lstStyle/>
-          <a:p>
-            <a:pPr algn="l"/>
-            <a:r>
-              <a:rPr sz="1300" b="0" i="0">
-                <a:solidFill>
-                  <a:srgbClr val="757575"/>
-                </a:solidFill>
-              </a:rPr>
-              <a:t>Bad Rate Reduction</a:t>
-            </a:r>
-          </a:p>
-        </p:txBody>
-      </p:sp>
-      <p:sp>
-        <p:nvSpPr>
-          <p:cNvPr id="14" name="TextBox 13"/>
-          <p:cNvSpPr txBox="1"/>
-          <p:nvPr/>
-        </p:nvSpPr>
-        <p:spPr>
-          <a:xfrm>
-            <a:off x="10058400" y="3008375"/>
-            <a:ext cx="1737360" cy="320040"/>
-          </a:xfrm>
-          <a:prstGeom prst="rect">
-            <a:avLst/>
-          </a:prstGeom>
-          <a:noFill/>
-        </p:spPr>
-        <p:txBody>
-          <a:bodyPr wrap="square">
-            <a:spAutoFit/>
-          </a:bodyPr>
-          <a:lstStyle/>
-          <a:p>
-            <a:pPr algn="r"/>
-            <a:r>
-              <a:rPr sz="1600" b="1" i="0">
-                <a:solidFill>
-                  <a:srgbClr val="2E7D32"/>
-                </a:solidFill>
-              </a:rPr>
-              <a:t>−20.5%</a:t>
-            </a:r>
-          </a:p>
-        </p:txBody>
-      </p:sp>
-      <p:sp>
-        <p:nvSpPr>
-          <p:cNvPr id="15" name="Rectangle 14"/>
-          <p:cNvSpPr/>
-          <p:nvPr/>
-        </p:nvSpPr>
-        <p:spPr>
-          <a:xfrm>
-            <a:off x="274320" y="3355847"/>
-            <a:ext cx="11612880" cy="18288"/>
-          </a:xfrm>
-          <a:prstGeom prst="rect">
-            <a:avLst/>
-          </a:prstGeom>
-          <a:solidFill>
-            <a:srgbClr val="F5F5F5"/>
-          </a:solidFill>
-          <a:ln>
-            <a:noFill/>
-          </a:ln>
-        </p:spPr>
-        <p:style>
-          <a:lnRef idx="1">
-            <a:schemeClr val="accent1"/>
-          </a:lnRef>
-          <a:fillRef idx="3">
-            <a:schemeClr val="accent1"/>
-          </a:fillRef>
-          <a:effectRef idx="2">
-            <a:schemeClr val="accent1"/>
-          </a:effectRef>
-          <a:fontRef idx="minor">
-            <a:schemeClr val="lt1"/>
-          </a:fontRef>
-        </p:style>
-        <p:txBody>
-          <a:bodyPr rtlCol="0" anchor="ctr"/>
-          <a:lstStyle/>
-          <a:p>
-            <a:pPr algn="ctr"/>
-          </a:p>
-        </p:txBody>
-      </p:sp>
-      <p:sp>
-        <p:nvSpPr>
-          <p:cNvPr id="16" name="TextBox 15"/>
-          <p:cNvSpPr txBox="1"/>
-          <p:nvPr/>
-        </p:nvSpPr>
-        <p:spPr>
-          <a:xfrm>
-            <a:off x="7589520" y="3575303"/>
-            <a:ext cx="2926080" cy="320040"/>
-          </a:xfrm>
-          <a:prstGeom prst="rect">
-            <a:avLst/>
-          </a:prstGeom>
-          <a:noFill/>
-        </p:spPr>
-        <p:txBody>
-          <a:bodyPr wrap="square">
-            <a:spAutoFit/>
-          </a:bodyPr>
-          <a:lstStyle/>
-          <a:p>
-            <a:pPr algn="l"/>
-            <a:r>
-              <a:rPr sz="1300" b="0" i="0">
-                <a:solidFill>
-                  <a:srgbClr val="757575"/>
-                </a:solidFill>
-              </a:rPr>
-              <a:t>Good Loans Lost</a:t>
-            </a:r>
-          </a:p>
-        </p:txBody>
-      </p:sp>
-      <p:sp>
-        <p:nvSpPr>
-          <p:cNvPr id="17" name="TextBox 16"/>
-          <p:cNvSpPr txBox="1"/>
-          <p:nvPr/>
-        </p:nvSpPr>
-        <p:spPr>
-          <a:xfrm>
-            <a:off x="10058400" y="3575303"/>
-            <a:ext cx="1737360" cy="320040"/>
-          </a:xfrm>
-          <a:prstGeom prst="rect">
-            <a:avLst/>
-          </a:prstGeom>
-          <a:noFill/>
-        </p:spPr>
-        <p:txBody>
-          <a:bodyPr wrap="square">
-            <a:spAutoFit/>
-          </a:bodyPr>
-          <a:lstStyle/>
-          <a:p>
-            <a:pPr algn="r"/>
-            <a:r>
-              <a:rPr sz="1600" b="1" i="0">
-                <a:solidFill>
-                  <a:srgbClr val="EF5350"/>
-                </a:solidFill>
-              </a:rPr>
-              <a:t>40.5%</a:t>
-            </a:r>
-          </a:p>
-        </p:txBody>
-      </p:sp>
-      <p:sp>
-        <p:nvSpPr>
-          <p:cNvPr id="18" name="Rectangle 17"/>
-          <p:cNvSpPr/>
-          <p:nvPr/>
-        </p:nvSpPr>
-        <p:spPr>
-          <a:xfrm>
-            <a:off x="274320" y="3922775"/>
-            <a:ext cx="11612880" cy="18288"/>
-          </a:xfrm>
-          <a:prstGeom prst="rect">
-            <a:avLst/>
-          </a:prstGeom>
-          <a:solidFill>
-            <a:srgbClr val="F5F5F5"/>
-          </a:solidFill>
-          <a:ln>
-            <a:noFill/>
-          </a:ln>
-        </p:spPr>
-        <p:style>
-          <a:lnRef idx="1">
-            <a:schemeClr val="accent1"/>
-          </a:lnRef>
-          <a:fillRef idx="3">
-            <a:schemeClr val="accent1"/>
-          </a:fillRef>
-          <a:effectRef idx="2">
-            <a:schemeClr val="accent1"/>
-          </a:effectRef>
-          <a:fontRef idx="minor">
-            <a:schemeClr val="lt1"/>
-          </a:fontRef>
-        </p:style>
-        <p:txBody>
-          <a:bodyPr rtlCol="0" anchor="ctr"/>
-          <a:lstStyle/>
-          <a:p>
-            <a:pPr algn="ctr"/>
-          </a:p>
-        </p:txBody>
-      </p:sp>
-      <p:sp>
-        <p:nvSpPr>
-          <p:cNvPr id="19" name="Rectangle 18"/>
-          <p:cNvSpPr/>
-          <p:nvPr/>
-        </p:nvSpPr>
-        <p:spPr>
-          <a:xfrm>
-            <a:off x="7498079" y="4206240"/>
-            <a:ext cx="4389120" cy="731520"/>
-          </a:xfrm>
-          <a:prstGeom prst="rect">
-            <a:avLst/>
-          </a:prstGeom>
-          <a:solidFill>
-            <a:srgbClr val="E3F2FD"/>
-          </a:solidFill>
-          <a:ln>
-            <a:noFill/>
-          </a:ln>
-        </p:spPr>
-        <p:style>
-          <a:lnRef idx="1">
-            <a:schemeClr val="accent1"/>
-          </a:lnRef>
-          <a:fillRef idx="3">
-            <a:schemeClr val="accent1"/>
-          </a:fillRef>
-          <a:effectRef idx="2">
-            <a:schemeClr val="accent1"/>
-          </a:effectRef>
-          <a:fontRef idx="minor">
-            <a:schemeClr val="lt1"/>
-          </a:fontRef>
-        </p:style>
-        <p:txBody>
-          <a:bodyPr rtlCol="0" anchor="ctr"/>
-          <a:lstStyle/>
-          <a:p>
-            <a:pPr algn="ctr"/>
-          </a:p>
-        </p:txBody>
-      </p:sp>
-      <p:sp>
-        <p:nvSpPr>
-          <p:cNvPr id="20" name="TextBox 19"/>
-          <p:cNvSpPr txBox="1"/>
-          <p:nvPr/>
-        </p:nvSpPr>
-        <p:spPr>
-          <a:xfrm>
-            <a:off x="7589520" y="4251960"/>
-            <a:ext cx="4206240" cy="685800"/>
-          </a:xfrm>
-          <a:prstGeom prst="rect">
-            <a:avLst/>
-          </a:prstGeom>
-          <a:noFill/>
-        </p:spPr>
-        <p:txBody>
-          <a:bodyPr wrap="square">
-            <a:spAutoFit/>
-          </a:bodyPr>
-          <a:lstStyle/>
-          <a:p>
-            <a:pPr algn="l"/>
-            <a:r>
-              <a:rPr sz="1300" b="0" i="1">
-                <a:solidFill>
-                  <a:srgbClr val="0D47A1"/>
-                </a:solidFill>
-              </a:rPr>
-              <a:t>"Elbow" of the trade-off curve — meaningful risk
-reduction without catastrophic volume loss.</a:t>
-            </a:r>
-          </a:p>
-        </p:txBody>
-      </p:sp>
-      <p:pic>
-        <p:nvPicPr>
-          <p:cNvPr id="21" name="Picture 20" descr="ruleset_comparison.png"/>
-          <p:cNvPicPr>
-            <a:picLocks noChangeAspect="1"/>
-          </p:cNvPicPr>
-          <p:nvPr/>
-        </p:nvPicPr>
-        <p:blipFill>
-          <a:blip r:embed="rId3"/>
-          <a:stretch>
-            <a:fillRect/>
-          </a:stretch>
-        </p:blipFill>
-        <p:spPr>
-          <a:xfrm>
-            <a:off x="7498079" y="5074920"/>
-            <a:ext cx="4389120" cy="1600200"/>
+            <a:off x="320040" y="1097280"/>
+            <a:ext cx="7518400" cy="5130800"/>
           </a:xfrm>
           <a:prstGeom prst="rect">
             <a:avLst/>
@@ -6027,7 +5068,7 @@
 </file>
 
 <file path=ppt/slides/slide7.xml><?xml version="1.0" encoding="utf-8"?>
-<p:sld xmlns:a="http://schemas.openxmlformats.org/drawingml/2006/main" xmlns:p="http://schemas.openxmlformats.org/presentationml/2006/main" xmlns:r="http://schemas.openxmlformats.org/officeDocument/2006/relationships">
+<p:sld xmlns:a="http://schemas.openxmlformats.org/drawingml/2006/main" xmlns:r="http://schemas.openxmlformats.org/officeDocument/2006/relationships" xmlns:p="http://schemas.openxmlformats.org/presentationml/2006/main">
   <p:cSld>
     <p:spTree>
       <p:nvGrpSpPr>
@@ -6035,7 +5076,14 @@
         <p:cNvGrpSpPr/>
         <p:nvPr/>
       </p:nvGrpSpPr>
-      <p:grpSpPr/>
+      <p:grpSpPr>
+        <a:xfrm>
+          <a:off x="0" y="0"/>
+          <a:ext cx="0" cy="0"/>
+          <a:chOff x="0" y="0"/>
+          <a:chExt cx="0" cy="0"/>
+        </a:xfrm>
+      </p:grpSpPr>
       <p:sp>
         <p:nvSpPr>
           <p:cNvPr id="2" name="Rectangle 1"/>
@@ -6045,16 +5093,17 @@
         <p:spPr>
           <a:xfrm>
             <a:off x="0" y="0"/>
-            <a:ext cx="12191695" cy="1005840"/>
+            <a:ext cx="12192000" cy="6858000"/>
           </a:xfrm>
           <a:prstGeom prst="rect">
             <a:avLst/>
           </a:prstGeom>
           <a:solidFill>
-            <a:srgbClr val="0D47A1"/>
+            <a:srgbClr val="F9FAFB"/>
           </a:solidFill>
-          <a:ln>
+          <a:ln w="9525" cap="flat" cmpd="sng" algn="ctr">
             <a:noFill/>
+            <a:prstDash val="solid"/>
           </a:ln>
         </p:spPr>
         <p:style>
@@ -6076,6 +5125,7 @@
           <a:lstStyle/>
           <a:p>
             <a:pPr algn="ctr"/>
+            <a:endParaRPr/>
           </a:p>
         </p:txBody>
       </p:sp>
@@ -6087,8 +5137,8 @@
         </p:nvSpPr>
         <p:spPr>
           <a:xfrm>
-            <a:off x="320040" y="91440"/>
-            <a:ext cx="11521440" cy="777240"/>
+            <a:off x="317500" y="254000"/>
+            <a:ext cx="11518900" cy="635000"/>
           </a:xfrm>
           <a:prstGeom prst="rect">
             <a:avLst/>
@@ -6102,32 +5152,58 @@
           <a:lstStyle/>
           <a:p>
             <a:r>
-              <a:rPr b="1" sz="2700">
-                <a:solidFill>
-                  <a:srgbClr val="FFFFFF"/>
-                </a:solidFill>
+              <a:rPr sz="2200" b="1">
+                <a:solidFill>
+                  <a:srgbClr val="0A0E27"/>
+                </a:solidFill>
+                <a:latin typeface="Century Gothic"/>
+                <a:cs typeface="Segoe UI Semibold"/>
               </a:rPr>
-              <a:t>Recommendations &amp; Next Steps</a:t>
-            </a:r>
-          </a:p>
-        </p:txBody>
-      </p:sp>
-      <p:sp>
-        <p:nvSpPr>
-          <p:cNvPr id="4" name="Rectangle 3"/>
+              <a:t>Recommended Ruleset D: FICO &lt; 680  OR  Grade E/F/G  OR  Revol Util &gt; 80%</a:t>
+            </a:r>
+          </a:p>
+        </p:txBody>
+      </p:sp>
+      <p:pic>
+        <p:nvPicPr>
+          <p:cNvPr id="4" name="Picture 3" descr="efficient_frontier.png"/>
+          <p:cNvPicPr>
+            <a:picLocks noChangeAspect="1"/>
+          </p:cNvPicPr>
+          <p:nvPr/>
+        </p:nvPicPr>
+        <p:blipFill>
+          <a:blip r:embed="rId2"/>
+          <a:stretch>
+            <a:fillRect/>
+          </a:stretch>
+        </p:blipFill>
+        <p:spPr>
+          <a:xfrm>
+            <a:off x="91440" y="1097280"/>
+            <a:ext cx="7132320" cy="5303520"/>
+          </a:xfrm>
+          <a:prstGeom prst="rect">
+            <a:avLst/>
+          </a:prstGeom>
+        </p:spPr>
+      </p:pic>
+      <p:sp>
+        <p:nvSpPr>
+          <p:cNvPr id="5" name="Rectangle 4"/>
           <p:cNvSpPr/>
           <p:nvPr/>
         </p:nvSpPr>
         <p:spPr>
           <a:xfrm>
-            <a:off x="274320" y="1143000"/>
-            <a:ext cx="5486400" cy="475488"/>
+            <a:off x="7498079" y="1234440"/>
+            <a:ext cx="4389120" cy="502920"/>
           </a:xfrm>
           <a:prstGeom prst="rect">
             <a:avLst/>
           </a:prstGeom>
           <a:solidFill>
-            <a:srgbClr val="2E7D32"/>
+            <a:srgbClr val="3B82F6"/>
           </a:solidFill>
           <a:ln>
             <a:noFill/>
@@ -6152,19 +5228,20 @@
           <a:lstStyle/>
           <a:p>
             <a:pPr algn="ctr"/>
-          </a:p>
-        </p:txBody>
-      </p:sp>
-      <p:sp>
-        <p:nvSpPr>
-          <p:cNvPr id="5" name="TextBox 4"/>
+            <a:endParaRPr/>
+          </a:p>
+        </p:txBody>
+      </p:sp>
+      <p:sp>
+        <p:nvSpPr>
+          <p:cNvPr id="6" name="TextBox 5"/>
           <p:cNvSpPr txBox="1"/>
           <p:nvPr/>
         </p:nvSpPr>
         <p:spPr>
           <a:xfrm>
-            <a:off x="274320" y="1143000"/>
-            <a:ext cx="5486400" cy="475488"/>
+            <a:off x="7498079" y="1234440"/>
+            <a:ext cx="4389120" cy="502920"/>
           </a:xfrm>
           <a:prstGeom prst="rect">
             <a:avLst/>
@@ -6179,10 +5256,882 @@
           <a:p>
             <a:pPr algn="l"/>
             <a:r>
-              <a:rPr sz="1700" b="1" i="0">
+              <a:rPr sz="1600" b="1" i="0">
                 <a:solidFill>
                   <a:srgbClr val="FFFFFF"/>
                 </a:solidFill>
+                <a:latin typeface="Century Gothic"/>
+                <a:cs typeface="Segoe UI Semibold"/>
+              </a:rPr>
+              <a:t>  Ruleset D — Key Metrics</a:t>
+            </a:r>
+          </a:p>
+        </p:txBody>
+      </p:sp>
+      <p:sp>
+        <p:nvSpPr>
+          <p:cNvPr id="7" name="TextBox 6"/>
+          <p:cNvSpPr txBox="1"/>
+          <p:nvPr/>
+        </p:nvSpPr>
+        <p:spPr>
+          <a:xfrm>
+            <a:off x="7589520" y="1874519"/>
+            <a:ext cx="2926080" cy="320040"/>
+          </a:xfrm>
+          <a:prstGeom prst="rect">
+            <a:avLst/>
+          </a:prstGeom>
+          <a:noFill/>
+        </p:spPr>
+        <p:txBody>
+          <a:bodyPr wrap="square">
+            <a:spAutoFit/>
+          </a:bodyPr>
+          <a:lstStyle/>
+          <a:p>
+            <a:pPr algn="l"/>
+            <a:r>
+              <a:rPr sz="1400" b="0" i="0">
+                <a:solidFill>
+                  <a:srgbClr val="64748B"/>
+                </a:solidFill>
+                <a:latin typeface="Century Gothic"/>
+                <a:cs typeface="Segoe UI"/>
+              </a:rPr>
+              <a:t>Baseline bad rate</a:t>
+            </a:r>
+          </a:p>
+        </p:txBody>
+      </p:sp>
+      <p:sp>
+        <p:nvSpPr>
+          <p:cNvPr id="8" name="TextBox 7"/>
+          <p:cNvSpPr txBox="1"/>
+          <p:nvPr/>
+        </p:nvSpPr>
+        <p:spPr>
+          <a:xfrm>
+            <a:off x="10058400" y="1874519"/>
+            <a:ext cx="1737360" cy="320040"/>
+          </a:xfrm>
+          <a:prstGeom prst="rect">
+            <a:avLst/>
+          </a:prstGeom>
+          <a:noFill/>
+        </p:spPr>
+        <p:txBody>
+          <a:bodyPr wrap="square">
+            <a:spAutoFit/>
+          </a:bodyPr>
+          <a:lstStyle/>
+          <a:p>
+            <a:pPr algn="r"/>
+            <a:r>
+              <a:rPr sz="1600" b="1" i="0">
+                <a:solidFill>
+                  <a:srgbClr val="3B82F6"/>
+                </a:solidFill>
+                <a:latin typeface="Century Gothic"/>
+                <a:cs typeface="Segoe UI Semibold"/>
+              </a:rPr>
+              <a:t>19.5%</a:t>
+            </a:r>
+          </a:p>
+        </p:txBody>
+      </p:sp>
+      <p:sp>
+        <p:nvSpPr>
+          <p:cNvPr id="9" name="Rectangle 8"/>
+          <p:cNvSpPr/>
+          <p:nvPr/>
+        </p:nvSpPr>
+        <p:spPr>
+          <a:xfrm>
+            <a:off x="274320" y="2221991"/>
+            <a:ext cx="11612880" cy="18288"/>
+          </a:xfrm>
+          <a:prstGeom prst="rect">
+            <a:avLst/>
+          </a:prstGeom>
+          <a:solidFill>
+            <a:srgbClr val="E2E8F0"/>
+          </a:solidFill>
+          <a:ln>
+            <a:noFill/>
+          </a:ln>
+        </p:spPr>
+        <p:style>
+          <a:lnRef idx="1">
+            <a:schemeClr val="accent1"/>
+          </a:lnRef>
+          <a:fillRef idx="3">
+            <a:schemeClr val="accent1"/>
+          </a:fillRef>
+          <a:effectRef idx="2">
+            <a:schemeClr val="accent1"/>
+          </a:effectRef>
+          <a:fontRef idx="minor">
+            <a:schemeClr val="lt1"/>
+          </a:fontRef>
+        </p:style>
+        <p:txBody>
+          <a:bodyPr rtlCol="0" anchor="ctr"/>
+          <a:lstStyle/>
+          <a:p>
+            <a:pPr algn="ctr"/>
+            <a:endParaRPr/>
+          </a:p>
+        </p:txBody>
+      </p:sp>
+      <p:sp>
+        <p:nvSpPr>
+          <p:cNvPr id="10" name="TextBox 9"/>
+          <p:cNvSpPr txBox="1"/>
+          <p:nvPr/>
+        </p:nvSpPr>
+        <p:spPr>
+          <a:xfrm>
+            <a:off x="7589520" y="2441447"/>
+            <a:ext cx="2926080" cy="320040"/>
+          </a:xfrm>
+          <a:prstGeom prst="rect">
+            <a:avLst/>
+          </a:prstGeom>
+          <a:noFill/>
+        </p:spPr>
+        <p:txBody>
+          <a:bodyPr wrap="square">
+            <a:spAutoFit/>
+          </a:bodyPr>
+          <a:lstStyle/>
+          <a:p>
+            <a:pPr algn="l"/>
+            <a:r>
+              <a:rPr sz="1400" b="0" i="0">
+                <a:solidFill>
+                  <a:srgbClr val="64748B"/>
+                </a:solidFill>
+                <a:latin typeface="Century Gothic"/>
+                <a:cs typeface="Segoe UI"/>
+              </a:rPr>
+              <a:t>New bad rate</a:t>
+            </a:r>
+          </a:p>
+        </p:txBody>
+      </p:sp>
+      <p:sp>
+        <p:nvSpPr>
+          <p:cNvPr id="11" name="TextBox 10"/>
+          <p:cNvSpPr txBox="1"/>
+          <p:nvPr/>
+        </p:nvSpPr>
+        <p:spPr>
+          <a:xfrm>
+            <a:off x="10058400" y="2441447"/>
+            <a:ext cx="1737360" cy="320040"/>
+          </a:xfrm>
+          <a:prstGeom prst="rect">
+            <a:avLst/>
+          </a:prstGeom>
+          <a:noFill/>
+        </p:spPr>
+        <p:txBody>
+          <a:bodyPr wrap="square">
+            <a:spAutoFit/>
+          </a:bodyPr>
+          <a:lstStyle/>
+          <a:p>
+            <a:pPr algn="r"/>
+            <a:r>
+              <a:rPr sz="1600" b="1" i="0">
+                <a:solidFill>
+                  <a:srgbClr val="3B82F6"/>
+                </a:solidFill>
+                <a:latin typeface="Century Gothic"/>
+                <a:cs typeface="Segoe UI Semibold"/>
+              </a:rPr>
+              <a:t>15.5%</a:t>
+            </a:r>
+          </a:p>
+        </p:txBody>
+      </p:sp>
+      <p:sp>
+        <p:nvSpPr>
+          <p:cNvPr id="12" name="Rectangle 11"/>
+          <p:cNvSpPr/>
+          <p:nvPr/>
+        </p:nvSpPr>
+        <p:spPr>
+          <a:xfrm>
+            <a:off x="274320" y="2788919"/>
+            <a:ext cx="11612880" cy="18288"/>
+          </a:xfrm>
+          <a:prstGeom prst="rect">
+            <a:avLst/>
+          </a:prstGeom>
+          <a:solidFill>
+            <a:srgbClr val="E2E8F0"/>
+          </a:solidFill>
+          <a:ln>
+            <a:noFill/>
+          </a:ln>
+        </p:spPr>
+        <p:style>
+          <a:lnRef idx="1">
+            <a:schemeClr val="accent1"/>
+          </a:lnRef>
+          <a:fillRef idx="3">
+            <a:schemeClr val="accent1"/>
+          </a:fillRef>
+          <a:effectRef idx="2">
+            <a:schemeClr val="accent1"/>
+          </a:effectRef>
+          <a:fontRef idx="minor">
+            <a:schemeClr val="lt1"/>
+          </a:fontRef>
+        </p:style>
+        <p:txBody>
+          <a:bodyPr rtlCol="0" anchor="ctr"/>
+          <a:lstStyle/>
+          <a:p>
+            <a:pPr algn="ctr"/>
+            <a:endParaRPr/>
+          </a:p>
+        </p:txBody>
+      </p:sp>
+      <p:sp>
+        <p:nvSpPr>
+          <p:cNvPr id="13" name="TextBox 12"/>
+          <p:cNvSpPr txBox="1"/>
+          <p:nvPr/>
+        </p:nvSpPr>
+        <p:spPr>
+          <a:xfrm>
+            <a:off x="7589520" y="3008375"/>
+            <a:ext cx="2926080" cy="320040"/>
+          </a:xfrm>
+          <a:prstGeom prst="rect">
+            <a:avLst/>
+          </a:prstGeom>
+          <a:noFill/>
+        </p:spPr>
+        <p:txBody>
+          <a:bodyPr wrap="square">
+            <a:spAutoFit/>
+          </a:bodyPr>
+          <a:lstStyle/>
+          <a:p>
+            <a:pPr algn="l"/>
+            <a:r>
+              <a:rPr sz="1400" b="0" i="0">
+                <a:solidFill>
+                  <a:srgbClr val="64748B"/>
+                </a:solidFill>
+                <a:latin typeface="Century Gothic"/>
+                <a:cs typeface="Segoe UI"/>
+              </a:rPr>
+              <a:t>Bad rate reduction</a:t>
+            </a:r>
+          </a:p>
+        </p:txBody>
+      </p:sp>
+      <p:sp>
+        <p:nvSpPr>
+          <p:cNvPr id="14" name="TextBox 13"/>
+          <p:cNvSpPr txBox="1"/>
+          <p:nvPr/>
+        </p:nvSpPr>
+        <p:spPr>
+          <a:xfrm>
+            <a:off x="10058400" y="3008375"/>
+            <a:ext cx="1737360" cy="320040"/>
+          </a:xfrm>
+          <a:prstGeom prst="rect">
+            <a:avLst/>
+          </a:prstGeom>
+          <a:noFill/>
+        </p:spPr>
+        <p:txBody>
+          <a:bodyPr wrap="square">
+            <a:spAutoFit/>
+          </a:bodyPr>
+          <a:lstStyle/>
+          <a:p>
+            <a:pPr algn="r"/>
+            <a:r>
+              <a:rPr sz="1600" b="1" i="0">
+                <a:solidFill>
+                  <a:srgbClr val="3B82F6"/>
+                </a:solidFill>
+                <a:latin typeface="Century Gothic"/>
+                <a:cs typeface="Segoe UI Semibold"/>
+              </a:rPr>
+              <a:t>−4.0 pp (20.5%)</a:t>
+            </a:r>
+          </a:p>
+        </p:txBody>
+      </p:sp>
+      <p:sp>
+        <p:nvSpPr>
+          <p:cNvPr id="15" name="Rectangle 14"/>
+          <p:cNvSpPr/>
+          <p:nvPr/>
+        </p:nvSpPr>
+        <p:spPr>
+          <a:xfrm>
+            <a:off x="274320" y="3355847"/>
+            <a:ext cx="11612880" cy="18288"/>
+          </a:xfrm>
+          <a:prstGeom prst="rect">
+            <a:avLst/>
+          </a:prstGeom>
+          <a:solidFill>
+            <a:srgbClr val="E2E8F0"/>
+          </a:solidFill>
+          <a:ln>
+            <a:noFill/>
+          </a:ln>
+        </p:spPr>
+        <p:style>
+          <a:lnRef idx="1">
+            <a:schemeClr val="accent1"/>
+          </a:lnRef>
+          <a:fillRef idx="3">
+            <a:schemeClr val="accent1"/>
+          </a:fillRef>
+          <a:effectRef idx="2">
+            <a:schemeClr val="accent1"/>
+          </a:effectRef>
+          <a:fontRef idx="minor">
+            <a:schemeClr val="lt1"/>
+          </a:fontRef>
+        </p:style>
+        <p:txBody>
+          <a:bodyPr rtlCol="0" anchor="ctr"/>
+          <a:lstStyle/>
+          <a:p>
+            <a:pPr algn="ctr"/>
+            <a:endParaRPr/>
+          </a:p>
+        </p:txBody>
+      </p:sp>
+      <p:sp>
+        <p:nvSpPr>
+          <p:cNvPr id="16" name="TextBox 15"/>
+          <p:cNvSpPr txBox="1"/>
+          <p:nvPr/>
+        </p:nvSpPr>
+        <p:spPr>
+          <a:xfrm>
+            <a:off x="7589520" y="3575303"/>
+            <a:ext cx="2926080" cy="320040"/>
+          </a:xfrm>
+          <a:prstGeom prst="rect">
+            <a:avLst/>
+          </a:prstGeom>
+          <a:noFill/>
+        </p:spPr>
+        <p:txBody>
+          <a:bodyPr wrap="square">
+            <a:spAutoFit/>
+          </a:bodyPr>
+          <a:lstStyle/>
+          <a:p>
+            <a:pPr algn="l"/>
+            <a:r>
+              <a:rPr sz="1400" b="0" i="0">
+                <a:solidFill>
+                  <a:srgbClr val="64748B"/>
+                </a:solidFill>
+                <a:latin typeface="Century Gothic"/>
+                <a:cs typeface="Segoe UI"/>
+              </a:rPr>
+              <a:t>Volume declined</a:t>
+            </a:r>
+          </a:p>
+        </p:txBody>
+      </p:sp>
+      <p:sp>
+        <p:nvSpPr>
+          <p:cNvPr id="17" name="TextBox 16"/>
+          <p:cNvSpPr txBox="1"/>
+          <p:nvPr/>
+        </p:nvSpPr>
+        <p:spPr>
+          <a:xfrm>
+            <a:off x="10058400" y="3575303"/>
+            <a:ext cx="1737360" cy="320040"/>
+          </a:xfrm>
+          <a:prstGeom prst="rect">
+            <a:avLst/>
+          </a:prstGeom>
+          <a:noFill/>
+        </p:spPr>
+        <p:txBody>
+          <a:bodyPr wrap="square">
+            <a:spAutoFit/>
+          </a:bodyPr>
+          <a:lstStyle/>
+          <a:p>
+            <a:pPr algn="r"/>
+            <a:r>
+              <a:rPr sz="1600" b="1" i="0">
+                <a:solidFill>
+                  <a:srgbClr val="3B82F6"/>
+                </a:solidFill>
+                <a:latin typeface="Century Gothic"/>
+                <a:cs typeface="Segoe UI Semibold"/>
+              </a:rPr>
+              <a:t>43.3%</a:t>
+            </a:r>
+          </a:p>
+        </p:txBody>
+      </p:sp>
+      <p:sp>
+        <p:nvSpPr>
+          <p:cNvPr id="18" name="Rectangle 17"/>
+          <p:cNvSpPr/>
+          <p:nvPr/>
+        </p:nvSpPr>
+        <p:spPr>
+          <a:xfrm>
+            <a:off x="274320" y="3922775"/>
+            <a:ext cx="11612880" cy="18288"/>
+          </a:xfrm>
+          <a:prstGeom prst="rect">
+            <a:avLst/>
+          </a:prstGeom>
+          <a:solidFill>
+            <a:srgbClr val="E2E8F0"/>
+          </a:solidFill>
+          <a:ln>
+            <a:noFill/>
+          </a:ln>
+        </p:spPr>
+        <p:style>
+          <a:lnRef idx="1">
+            <a:schemeClr val="accent1"/>
+          </a:lnRef>
+          <a:fillRef idx="3">
+            <a:schemeClr val="accent1"/>
+          </a:fillRef>
+          <a:effectRef idx="2">
+            <a:schemeClr val="accent1"/>
+          </a:effectRef>
+          <a:fontRef idx="minor">
+            <a:schemeClr val="lt1"/>
+          </a:fontRef>
+        </p:style>
+        <p:txBody>
+          <a:bodyPr rtlCol="0" anchor="ctr"/>
+          <a:lstStyle/>
+          <a:p>
+            <a:pPr algn="ctr"/>
+            <a:endParaRPr/>
+          </a:p>
+        </p:txBody>
+      </p:sp>
+      <p:sp>
+        <p:nvSpPr>
+          <p:cNvPr id="19" name="TextBox 18"/>
+          <p:cNvSpPr txBox="1"/>
+          <p:nvPr/>
+        </p:nvSpPr>
+        <p:spPr>
+          <a:xfrm>
+            <a:off x="7589520" y="4142231"/>
+            <a:ext cx="2926080" cy="320040"/>
+          </a:xfrm>
+          <a:prstGeom prst="rect">
+            <a:avLst/>
+          </a:prstGeom>
+          <a:noFill/>
+        </p:spPr>
+        <p:txBody>
+          <a:bodyPr wrap="square">
+            <a:spAutoFit/>
+          </a:bodyPr>
+          <a:lstStyle/>
+          <a:p>
+            <a:pPr algn="l"/>
+            <a:r>
+              <a:rPr sz="1400" b="0" i="0">
+                <a:solidFill>
+                  <a:srgbClr val="64748B"/>
+                </a:solidFill>
+                <a:latin typeface="Century Gothic"/>
+                <a:cs typeface="Segoe UI"/>
+              </a:rPr>
+              <a:t>Good loans lost</a:t>
+            </a:r>
+          </a:p>
+        </p:txBody>
+      </p:sp>
+      <p:sp>
+        <p:nvSpPr>
+          <p:cNvPr id="20" name="TextBox 19"/>
+          <p:cNvSpPr txBox="1"/>
+          <p:nvPr/>
+        </p:nvSpPr>
+        <p:spPr>
+          <a:xfrm>
+            <a:off x="10058400" y="4142231"/>
+            <a:ext cx="1737360" cy="320040"/>
+          </a:xfrm>
+          <a:prstGeom prst="rect">
+            <a:avLst/>
+          </a:prstGeom>
+          <a:noFill/>
+        </p:spPr>
+        <p:txBody>
+          <a:bodyPr wrap="square">
+            <a:spAutoFit/>
+          </a:bodyPr>
+          <a:lstStyle/>
+          <a:p>
+            <a:pPr algn="r"/>
+            <a:r>
+              <a:rPr sz="1600" b="1" i="0">
+                <a:solidFill>
+                  <a:srgbClr val="3B82F6"/>
+                </a:solidFill>
+                <a:latin typeface="Century Gothic"/>
+                <a:cs typeface="Segoe UI Semibold"/>
+              </a:rPr>
+              <a:t>40.5%</a:t>
+            </a:r>
+          </a:p>
+        </p:txBody>
+      </p:sp>
+      <p:sp>
+        <p:nvSpPr>
+          <p:cNvPr id="21" name="Rectangle 20"/>
+          <p:cNvSpPr/>
+          <p:nvPr/>
+        </p:nvSpPr>
+        <p:spPr>
+          <a:xfrm>
+            <a:off x="274320" y="4489703"/>
+            <a:ext cx="11612880" cy="18288"/>
+          </a:xfrm>
+          <a:prstGeom prst="rect">
+            <a:avLst/>
+          </a:prstGeom>
+          <a:solidFill>
+            <a:srgbClr val="E2E8F0"/>
+          </a:solidFill>
+          <a:ln>
+            <a:noFill/>
+          </a:ln>
+        </p:spPr>
+        <p:style>
+          <a:lnRef idx="1">
+            <a:schemeClr val="accent1"/>
+          </a:lnRef>
+          <a:fillRef idx="3">
+            <a:schemeClr val="accent1"/>
+          </a:fillRef>
+          <a:effectRef idx="2">
+            <a:schemeClr val="accent1"/>
+          </a:effectRef>
+          <a:fontRef idx="minor">
+            <a:schemeClr val="lt1"/>
+          </a:fontRef>
+        </p:style>
+        <p:txBody>
+          <a:bodyPr rtlCol="0" anchor="ctr"/>
+          <a:lstStyle/>
+          <a:p>
+            <a:pPr algn="ctr"/>
+            <a:endParaRPr/>
+          </a:p>
+        </p:txBody>
+      </p:sp>
+      <p:sp>
+        <p:nvSpPr>
+          <p:cNvPr id="22" name="Rectangle 21"/>
+          <p:cNvSpPr/>
+          <p:nvPr/>
+        </p:nvSpPr>
+        <p:spPr>
+          <a:xfrm>
+            <a:off x="7498079" y="4754880"/>
+            <a:ext cx="4389120" cy="822960"/>
+          </a:xfrm>
+          <a:prstGeom prst="rect">
+            <a:avLst/>
+          </a:prstGeom>
+          <a:solidFill>
+            <a:srgbClr val="EFF6FF"/>
+          </a:solidFill>
+          <a:ln>
+            <a:noFill/>
+          </a:ln>
+        </p:spPr>
+        <p:style>
+          <a:lnRef idx="1">
+            <a:schemeClr val="accent1"/>
+          </a:lnRef>
+          <a:fillRef idx="3">
+            <a:schemeClr val="accent1"/>
+          </a:fillRef>
+          <a:effectRef idx="2">
+            <a:schemeClr val="accent1"/>
+          </a:effectRef>
+          <a:fontRef idx="minor">
+            <a:schemeClr val="lt1"/>
+          </a:fontRef>
+        </p:style>
+        <p:txBody>
+          <a:bodyPr rtlCol="0" anchor="ctr"/>
+          <a:lstStyle/>
+          <a:p>
+            <a:pPr algn="ctr"/>
+            <a:endParaRPr/>
+          </a:p>
+        </p:txBody>
+      </p:sp>
+      <p:sp>
+        <p:nvSpPr>
+          <p:cNvPr id="23" name="TextBox 22"/>
+          <p:cNvSpPr txBox="1"/>
+          <p:nvPr/>
+        </p:nvSpPr>
+        <p:spPr>
+          <a:xfrm>
+            <a:off x="7589520" y="4800600"/>
+            <a:ext cx="4206240" cy="749808"/>
+          </a:xfrm>
+          <a:prstGeom prst="rect">
+            <a:avLst/>
+          </a:prstGeom>
+          <a:noFill/>
+        </p:spPr>
+        <p:txBody>
+          <a:bodyPr wrap="square">
+            <a:spAutoFit/>
+          </a:bodyPr>
+          <a:lstStyle/>
+          <a:p>
+            <a:pPr algn="l"/>
+            <a:r>
+              <a:rPr sz="1400" b="0" i="1">
+                <a:solidFill>
+                  <a:srgbClr val="0A0E27"/>
+                </a:solidFill>
+                <a:latin typeface="Century Gothic"/>
+                <a:cs typeface="Segoe UI"/>
+              </a:rPr>
+              <a:t>"Elbow" of the efficient frontier — meaningful risk
+reduction without catastrophic volume loss.</a:t>
+            </a:r>
+          </a:p>
+        </p:txBody>
+      </p:sp>
+      <p:pic>
+        <p:nvPicPr>
+          <p:cNvPr id="24" name="Picture 23" descr="ruleset_comparison.png"/>
+          <p:cNvPicPr>
+            <a:picLocks noChangeAspect="1"/>
+          </p:cNvPicPr>
+          <p:nvPr/>
+        </p:nvPicPr>
+        <p:blipFill>
+          <a:blip r:embed="rId3"/>
+          <a:stretch>
+            <a:fillRect/>
+          </a:stretch>
+        </p:blipFill>
+        <p:spPr>
+          <a:xfrm>
+            <a:off x="7498079" y="5715000"/>
+            <a:ext cx="4389120" cy="960120"/>
+          </a:xfrm>
+          <a:prstGeom prst="rect">
+            <a:avLst/>
+          </a:prstGeom>
+        </p:spPr>
+      </p:pic>
+    </p:spTree>
+  </p:cSld>
+  <p:clrMapOvr>
+    <a:masterClrMapping/>
+  </p:clrMapOvr>
+</p:sld>
+</file>
+
+<file path=ppt/slides/slide8.xml><?xml version="1.0" encoding="utf-8"?>
+<p:sld xmlns:a="http://schemas.openxmlformats.org/drawingml/2006/main" xmlns:r="http://schemas.openxmlformats.org/officeDocument/2006/relationships" xmlns:p="http://schemas.openxmlformats.org/presentationml/2006/main">
+  <p:cSld>
+    <p:spTree>
+      <p:nvGrpSpPr>
+        <p:cNvPr id="1" name=""/>
+        <p:cNvGrpSpPr/>
+        <p:nvPr/>
+      </p:nvGrpSpPr>
+      <p:grpSpPr>
+        <a:xfrm>
+          <a:off x="0" y="0"/>
+          <a:ext cx="0" cy="0"/>
+          <a:chOff x="0" y="0"/>
+          <a:chExt cx="0" cy="0"/>
+        </a:xfrm>
+      </p:grpSpPr>
+      <p:sp>
+        <p:nvSpPr>
+          <p:cNvPr id="2" name="Rectangle 1"/>
+          <p:cNvSpPr/>
+          <p:nvPr/>
+        </p:nvSpPr>
+        <p:spPr>
+          <a:xfrm>
+            <a:off x="0" y="0"/>
+            <a:ext cx="12192000" cy="6858000"/>
+          </a:xfrm>
+          <a:prstGeom prst="rect">
+            <a:avLst/>
+          </a:prstGeom>
+          <a:solidFill>
+            <a:srgbClr val="F9FAFB"/>
+          </a:solidFill>
+          <a:ln w="9525" cap="flat" cmpd="sng" algn="ctr">
+            <a:noFill/>
+            <a:prstDash val="solid"/>
+          </a:ln>
+        </p:spPr>
+        <p:style>
+          <a:lnRef idx="1">
+            <a:schemeClr val="accent1"/>
+          </a:lnRef>
+          <a:fillRef idx="3">
+            <a:schemeClr val="accent1"/>
+          </a:fillRef>
+          <a:effectRef idx="2">
+            <a:schemeClr val="accent1"/>
+          </a:effectRef>
+          <a:fontRef idx="minor">
+            <a:schemeClr val="lt1"/>
+          </a:fontRef>
+        </p:style>
+        <p:txBody>
+          <a:bodyPr rtlCol="0" anchor="ctr"/>
+          <a:lstStyle/>
+          <a:p>
+            <a:pPr algn="ctr"/>
+            <a:endParaRPr/>
+          </a:p>
+        </p:txBody>
+      </p:sp>
+      <p:sp>
+        <p:nvSpPr>
+          <p:cNvPr id="3" name="TextBox 2"/>
+          <p:cNvSpPr txBox="1"/>
+          <p:nvPr/>
+        </p:nvSpPr>
+        <p:spPr>
+          <a:xfrm>
+            <a:off x="317500" y="254000"/>
+            <a:ext cx="11518900" cy="635000"/>
+          </a:xfrm>
+          <a:prstGeom prst="rect">
+            <a:avLst/>
+          </a:prstGeom>
+          <a:noFill/>
+        </p:spPr>
+        <p:txBody>
+          <a:bodyPr wrap="none">
+            <a:spAutoFit/>
+          </a:bodyPr>
+          <a:lstStyle/>
+          <a:p>
+            <a:r>
+              <a:rPr sz="2200" b="1">
+                <a:solidFill>
+                  <a:srgbClr val="0A0E27"/>
+                </a:solidFill>
+                <a:latin typeface="Century Gothic"/>
+                <a:cs typeface="Segoe UI Semibold"/>
+              </a:rPr>
+              <a:t>Recommendations &amp; Next Steps</a:t>
+            </a:r>
+          </a:p>
+        </p:txBody>
+      </p:sp>
+      <p:sp>
+        <p:nvSpPr>
+          <p:cNvPr id="4" name="Rectangle 3"/>
+          <p:cNvSpPr/>
+          <p:nvPr/>
+        </p:nvSpPr>
+        <p:spPr>
+          <a:xfrm>
+            <a:off x="274320" y="1143000"/>
+            <a:ext cx="5486400" cy="475488"/>
+          </a:xfrm>
+          <a:prstGeom prst="rect">
+            <a:avLst/>
+          </a:prstGeom>
+          <a:solidFill>
+            <a:srgbClr val="3B82F6"/>
+          </a:solidFill>
+          <a:ln>
+            <a:noFill/>
+          </a:ln>
+        </p:spPr>
+        <p:style>
+          <a:lnRef idx="1">
+            <a:schemeClr val="accent1"/>
+          </a:lnRef>
+          <a:fillRef idx="3">
+            <a:schemeClr val="accent1"/>
+          </a:fillRef>
+          <a:effectRef idx="2">
+            <a:schemeClr val="accent1"/>
+          </a:effectRef>
+          <a:fontRef idx="minor">
+            <a:schemeClr val="lt1"/>
+          </a:fontRef>
+        </p:style>
+        <p:txBody>
+          <a:bodyPr rtlCol="0" anchor="ctr"/>
+          <a:lstStyle/>
+          <a:p>
+            <a:pPr algn="ctr"/>
+            <a:endParaRPr/>
+          </a:p>
+        </p:txBody>
+      </p:sp>
+      <p:sp>
+        <p:nvSpPr>
+          <p:cNvPr id="5" name="TextBox 4"/>
+          <p:cNvSpPr txBox="1"/>
+          <p:nvPr/>
+        </p:nvSpPr>
+        <p:spPr>
+          <a:xfrm>
+            <a:off x="274320" y="1143000"/>
+            <a:ext cx="5486400" cy="475488"/>
+          </a:xfrm>
+          <a:prstGeom prst="rect">
+            <a:avLst/>
+          </a:prstGeom>
+          <a:noFill/>
+        </p:spPr>
+        <p:txBody>
+          <a:bodyPr wrap="square">
+            <a:spAutoFit/>
+          </a:bodyPr>
+          <a:lstStyle/>
+          <a:p>
+            <a:pPr algn="l"/>
+            <a:r>
+              <a:rPr sz="1600" b="1" i="0">
+                <a:solidFill>
+                  <a:srgbClr val="FFFFFF"/>
+                </a:solidFill>
+                <a:latin typeface="Century Gothic"/>
+                <a:cs typeface="Segoe UI Semibold"/>
               </a:rPr>
               <a:t>  ✓  Implement Now</a:t>
             </a:r>
@@ -6219,8 +6168,10 @@
             <a:r>
               <a:rPr sz="1400">
                 <a:solidFill>
-                  <a:srgbClr val="424242"/>
-                </a:solidFill>
+                  <a:srgbClr val="0A0E27"/>
+                </a:solidFill>
+                <a:latin typeface="Century Gothic"/>
+                <a:cs typeface="Segoe UI"/>
               </a:rPr>
               <a:t>Decline if FICO &lt; 680
   → strongest single predictor; 2× baseline bad rate</a:t>
@@ -6235,8 +6186,10 @@
             <a:r>
               <a:rPr sz="1400">
                 <a:solidFill>
-                  <a:srgbClr val="424242"/>
-                </a:solidFill>
+                  <a:srgbClr val="0A0E27"/>
+                </a:solidFill>
+                <a:latin typeface="Century Gothic"/>
+                <a:cs typeface="Segoe UI"/>
               </a:rPr>
               <a:t>Decline if Loan Grade E, F, or G
   → Lending Club's own risk model endorses these thresholds</a:t>
@@ -6251,8 +6204,10 @@
             <a:r>
               <a:rPr sz="1400">
                 <a:solidFill>
-                  <a:srgbClr val="424242"/>
-                </a:solidFill>
+                  <a:srgbClr val="0A0E27"/>
+                </a:solidFill>
+                <a:latin typeface="Century Gothic"/>
+                <a:cs typeface="Segoe UI"/>
               </a:rPr>
               <a:t>Decline if Revolving Utilization &gt; 80%
   → captures financial stress independent of credit score</a:t>
@@ -6267,8 +6222,10 @@
             <a:r>
               <a:rPr sz="1400">
                 <a:solidFill>
-                  <a:srgbClr val="424242"/>
-                </a:solidFill>
+                  <a:srgbClr val="0A0E27"/>
+                </a:solidFill>
+                <a:latin typeface="Century Gothic"/>
+                <a:cs typeface="Segoe UI"/>
               </a:rPr>
               <a:t>Add Bankruptcy as a hard cutoff (any record)
   → categorical signal; no exceptions policy</a:t>
@@ -6291,7 +6248,7 @@
             <a:avLst/>
           </a:prstGeom>
           <a:solidFill>
-            <a:srgbClr val="0D47A1"/>
+            <a:srgbClr val="0A0E27"/>
           </a:solidFill>
           <a:ln>
             <a:noFill/>
@@ -6316,6 +6273,7 @@
           <a:lstStyle/>
           <a:p>
             <a:pPr algn="ctr"/>
+            <a:endParaRPr/>
           </a:p>
         </p:txBody>
       </p:sp>
@@ -6343,10 +6301,12 @@
           <a:p>
             <a:pPr algn="l"/>
             <a:r>
-              <a:rPr sz="1700" b="1" i="0">
+              <a:rPr sz="1600" b="1" i="0">
                 <a:solidFill>
                   <a:srgbClr val="FFFFFF"/>
                 </a:solidFill>
+                <a:latin typeface="Century Gothic"/>
+                <a:cs typeface="Segoe UI Semibold"/>
               </a:rPr>
               <a:t>  →  Future Improvements</a:t>
             </a:r>
@@ -6383,8 +6343,10 @@
             <a:r>
               <a:rPr sz="1400">
                 <a:solidFill>
-                  <a:srgbClr val="424242"/>
-                </a:solidFill>
+                  <a:srgbClr val="0A0E27"/>
+                </a:solidFill>
+                <a:latin typeface="Century Gothic"/>
+                <a:cs typeface="Segoe UI"/>
               </a:rPr>
               <a:t>Build a logistic regression scorecard
   → replace hard cutoffs with a continuous risk score; tune threshold at any desired approval rate</a:t>
@@ -6399,8 +6361,10 @@
             <a:r>
               <a:rPr sz="1400">
                 <a:solidFill>
-                  <a:srgbClr val="424242"/>
-                </a:solidFill>
+                  <a:srgbClr val="0A0E27"/>
+                </a:solidFill>
+                <a:latin typeface="Century Gothic"/>
+                <a:cs typeface="Segoe UI"/>
               </a:rPr>
               <a:t>Vintage analysis
   → calibrate rules on recent cohorts (2017–2019) to avoid over-weighting the 2008 crisis</a:t>
@@ -6415,8 +6379,10 @@
             <a:r>
               <a:rPr sz="1400">
                 <a:solidFill>
-                  <a:srgbClr val="424242"/>
-                </a:solidFill>
+                  <a:srgbClr val="0A0E27"/>
+                </a:solidFill>
+                <a:latin typeface="Century Gothic"/>
+                <a:cs typeface="Segoe UI"/>
               </a:rPr>
               <a:t>Purpose-specific policies
   → small business loans (26% bad rate) may need a separate, stricter policy</a:t>
@@ -6431,8 +6397,10 @@
             <a:r>
               <a:rPr sz="1400">
                 <a:solidFill>
-                  <a:srgbClr val="424242"/>
-                </a:solidFill>
+                  <a:srgbClr val="0A0E27"/>
+                </a:solidFill>
+                <a:latin typeface="Century Gothic"/>
+                <a:cs typeface="Segoe UI"/>
               </a:rPr>
               <a:t>A/B test the rollout
   → measure real approval rate impact before full deployment</a:t>
@@ -6455,7 +6423,7 @@
             <a:avLst/>
           </a:prstGeom>
           <a:solidFill>
-            <a:srgbClr val="F5F5F5"/>
+            <a:srgbClr val="F1F5F9"/>
           </a:solidFill>
           <a:ln>
             <a:noFill/>
@@ -6480,6 +6448,7 @@
           <a:lstStyle/>
           <a:p>
             <a:pPr algn="ctr"/>
+            <a:endParaRPr/>
           </a:p>
         </p:txBody>
       </p:sp>
@@ -6507,10 +6476,12 @@
           <a:p>
             <a:pPr algn="l"/>
             <a:r>
-              <a:rPr sz="1000" b="0" i="1">
-                <a:solidFill>
-                  <a:srgbClr val="757575"/>
-                </a:solidFill>
+              <a:rPr sz="1400" b="0" i="1">
+                <a:solidFill>
+                  <a:srgbClr val="94A3B8"/>
+                </a:solidFill>
+                <a:latin typeface="Century Gothic"/>
+                <a:cs typeface="Segoe UI"/>
               </a:rPr>
               <a:t>All rules use only origination-time data  ·  No post-loan information used  ·  Analysis based on 1,860,331 Lending Club loans 2007–2020 Q3</a:t>
             </a:r>
@@ -6843,4 +6814,26 @@
   </a:objectDefaults>
   <a:extraClrSchemeLst/>
 </a:theme>
+</file>
+
+<file path=ppt/webextensions/taskpanes.xml><?xml version="1.0" encoding="utf-8"?>
+<wetp:taskpanes xmlns:wetp="http://schemas.microsoft.com/office/webextensions/taskpanes/2010/11">
+  <wetp:taskpane dockstate="right" visibility="0" width="350" row="0">
+    <wetp:webextensionref xmlns:r="http://schemas.openxmlformats.org/officeDocument/2006/relationships" r:id="rId1"/>
+  </wetp:taskpane>
+</wetp:taskpanes>
+</file>
+
+<file path=ppt/webextensions/webextension1.xml><?xml version="1.0" encoding="utf-8"?>
+<we:webextension xmlns:we="http://schemas.microsoft.com/office/webextensions/webextension/2010/11" id="{8906EC8C-69A4-E74C-9273-AFA975E6744A}">
+  <we:reference id="wa200010001" version="1.0.0.0" store="en-US" storeType="OMEX"/>
+  <we:alternateReferences>
+    <we:reference id="wa200010001" version="1.0.0.0" store="" storeType="OMEX"/>
+  </we:alternateReferences>
+  <we:properties>
+    <we:property name="Office.AutoShowTaskpaneWithDocument" value="true"/>
+  </we:properties>
+  <we:bindings/>
+  <we:snapshot xmlns:r="http://schemas.openxmlformats.org/officeDocument/2006/relationships"/>
+</we:webextension>
 </file>
</xml_diff>